<commit_message>
Update ForgeX webinar skill placements
</commit_message>
<xml_diff>
--- a/webinar/2026-09-17-ai-for-abm-foundations/deliverables/forgex-ai-for-abm-webinar-deck.pptx
+++ b/webinar/2026-09-17-ai-for-abm-foundations/deliverables/forgex-ai-for-abm-webinar-deck.pptx
@@ -2,33 +2,33 @@
 <file path=ppt/presentation.xml><?xml version="1.0" encoding="utf-8"?>
 <p:presentation xmlns:p="http://schemas.openxmlformats.org/presentationml/2006/main">
   <p:sldMasterIdLst>
-    <p:sldMasterId xmlns:r="http://schemas.openxmlformats.org/officeDocument/2006/relationships" id="2147483648" r:id="R057bc7f3a29044e1"/>
+    <p:sldMasterId xmlns:r="http://schemas.openxmlformats.org/officeDocument/2006/relationships" id="2147483648" r:id="Re90f20a8cf9446ee"/>
   </p:sldMasterIdLst>
   <p:notesMasterIdLst>
-    <p:notesMasterId xmlns:r="http://schemas.openxmlformats.org/officeDocument/2006/relationships" r:id="R348283ae57114fe2"/>
+    <p:notesMasterId xmlns:r="http://schemas.openxmlformats.org/officeDocument/2006/relationships" r:id="Rbc4c7f1ef91543da"/>
   </p:notesMasterIdLst>
   <p:sldIdLst>
-    <p:sldId xmlns:r="http://schemas.openxmlformats.org/officeDocument/2006/relationships" id="256" r:id="R61991f2bd73a4a15"/>
-    <p:sldId xmlns:r="http://schemas.openxmlformats.org/officeDocument/2006/relationships" id="257" r:id="R9d2533b48fd34af5"/>
-    <p:sldId xmlns:r="http://schemas.openxmlformats.org/officeDocument/2006/relationships" id="258" r:id="R43fbfac072414536"/>
-    <p:sldId xmlns:r="http://schemas.openxmlformats.org/officeDocument/2006/relationships" id="259" r:id="R2df15b8232124295"/>
-    <p:sldId xmlns:r="http://schemas.openxmlformats.org/officeDocument/2006/relationships" id="260" r:id="R74a38bfa3b9c4bca"/>
-    <p:sldId xmlns:r="http://schemas.openxmlformats.org/officeDocument/2006/relationships" id="261" r:id="R94897d980b3e4a9a"/>
-    <p:sldId xmlns:r="http://schemas.openxmlformats.org/officeDocument/2006/relationships" id="262" r:id="R3947c349eb104346"/>
-    <p:sldId xmlns:r="http://schemas.openxmlformats.org/officeDocument/2006/relationships" id="263" r:id="Rbfbd6e30e71c4b25"/>
-    <p:sldId xmlns:r="http://schemas.openxmlformats.org/officeDocument/2006/relationships" id="264" r:id="Rd7b622fce54144bf"/>
-    <p:sldId xmlns:r="http://schemas.openxmlformats.org/officeDocument/2006/relationships" id="265" r:id="Rb860ed1241824795"/>
-    <p:sldId xmlns:r="http://schemas.openxmlformats.org/officeDocument/2006/relationships" id="266" r:id="R7cec8f2935bf4025"/>
-    <p:sldId xmlns:r="http://schemas.openxmlformats.org/officeDocument/2006/relationships" id="267" r:id="R6b28f07645df4a57"/>
-    <p:sldId xmlns:r="http://schemas.openxmlformats.org/officeDocument/2006/relationships" id="268" r:id="R9d47095d7a6642c7"/>
-    <p:sldId xmlns:r="http://schemas.openxmlformats.org/officeDocument/2006/relationships" id="269" r:id="R2dfd100ec6754b51"/>
-    <p:sldId xmlns:r="http://schemas.openxmlformats.org/officeDocument/2006/relationships" id="270" r:id="Rbbeb1ae505274cb9"/>
-    <p:sldId xmlns:r="http://schemas.openxmlformats.org/officeDocument/2006/relationships" id="271" r:id="Rb46497f4d5bf4b89"/>
-    <p:sldId xmlns:r="http://schemas.openxmlformats.org/officeDocument/2006/relationships" id="272" r:id="R53251cf6437e4ec5"/>
-    <p:sldId xmlns:r="http://schemas.openxmlformats.org/officeDocument/2006/relationships" id="273" r:id="Rd17d342498544b34"/>
-    <p:sldId xmlns:r="http://schemas.openxmlformats.org/officeDocument/2006/relationships" id="274" r:id="Rfedda95930ed47e5"/>
-    <p:sldId xmlns:r="http://schemas.openxmlformats.org/officeDocument/2006/relationships" id="275" r:id="R631393df1bfe4879"/>
-    <p:sldId xmlns:r="http://schemas.openxmlformats.org/officeDocument/2006/relationships" id="276" r:id="Re63c0662b94f4f40"/>
+    <p:sldId xmlns:r="http://schemas.openxmlformats.org/officeDocument/2006/relationships" id="256" r:id="R3e2c269f282242d0"/>
+    <p:sldId xmlns:r="http://schemas.openxmlformats.org/officeDocument/2006/relationships" id="257" r:id="R17503447ec7e4ca0"/>
+    <p:sldId xmlns:r="http://schemas.openxmlformats.org/officeDocument/2006/relationships" id="258" r:id="R620e0c4ff096488a"/>
+    <p:sldId xmlns:r="http://schemas.openxmlformats.org/officeDocument/2006/relationships" id="259" r:id="R15540b54ef644038"/>
+    <p:sldId xmlns:r="http://schemas.openxmlformats.org/officeDocument/2006/relationships" id="260" r:id="R9c1835d937154fbe"/>
+    <p:sldId xmlns:r="http://schemas.openxmlformats.org/officeDocument/2006/relationships" id="261" r:id="R4c7f64be0b2846a1"/>
+    <p:sldId xmlns:r="http://schemas.openxmlformats.org/officeDocument/2006/relationships" id="262" r:id="R3afb655c33e24114"/>
+    <p:sldId xmlns:r="http://schemas.openxmlformats.org/officeDocument/2006/relationships" id="263" r:id="R1750c11aebd64282"/>
+    <p:sldId xmlns:r="http://schemas.openxmlformats.org/officeDocument/2006/relationships" id="264" r:id="Rf56602042b954c66"/>
+    <p:sldId xmlns:r="http://schemas.openxmlformats.org/officeDocument/2006/relationships" id="265" r:id="Rd7ddf3b7a8e44275"/>
+    <p:sldId xmlns:r="http://schemas.openxmlformats.org/officeDocument/2006/relationships" id="266" r:id="Rcba55e90cfdd4a56"/>
+    <p:sldId xmlns:r="http://schemas.openxmlformats.org/officeDocument/2006/relationships" id="267" r:id="R4830026fc7004801"/>
+    <p:sldId xmlns:r="http://schemas.openxmlformats.org/officeDocument/2006/relationships" id="268" r:id="R138017b6b0bd498e"/>
+    <p:sldId xmlns:r="http://schemas.openxmlformats.org/officeDocument/2006/relationships" id="269" r:id="Ra6abc595c4d94357"/>
+    <p:sldId xmlns:r="http://schemas.openxmlformats.org/officeDocument/2006/relationships" id="270" r:id="Rd15cb86b458c44d3"/>
+    <p:sldId xmlns:r="http://schemas.openxmlformats.org/officeDocument/2006/relationships" id="271" r:id="Rd8ce20c310064c14"/>
+    <p:sldId xmlns:r="http://schemas.openxmlformats.org/officeDocument/2006/relationships" id="272" r:id="Rf8a6c790567346a1"/>
+    <p:sldId xmlns:r="http://schemas.openxmlformats.org/officeDocument/2006/relationships" id="273" r:id="R34674ce482ba4218"/>
+    <p:sldId xmlns:r="http://schemas.openxmlformats.org/officeDocument/2006/relationships" id="274" r:id="R81c3a15e47774ada"/>
+    <p:sldId xmlns:r="http://schemas.openxmlformats.org/officeDocument/2006/relationships" id="275" r:id="R0439af09085949f6"/>
+    <p:sldId xmlns:r="http://schemas.openxmlformats.org/officeDocument/2006/relationships" id="276" r:id="R8ec8640a05ec48b5"/>
   </p:sldIdLst>
   <p:sldSz cx="12192000" cy="6858000"/>
   <p:notesSz cx="6858000" cy="9144000"/>
@@ -817,12 +817,42 @@
           <a:lstStyle xmlns:a="http://schemas.openxmlformats.org/drawingml/2006/main"/>
           <a:p xmlns:a="http://schemas.openxmlformats.org/drawingml/2006/main">
             <a:r>
-              <a:t>Treat the community as a pattern library, not an app store. Keep 1:1 ABM Ads draft-only, with no live objects, activation, or spend. Audience ICP Filter has a conditional pass for reviewed list classification only: 22 synthetic attendees reconciled completely, nine required semantic review, and the corrected suite passes 45 of 45 checks. No enrichment, sending, CRM writes, or sequence enrollment.</a:t>
-            </a:r>
-          </a:p>
-          <a:p xmlns:a="http://schemas.openxmlformats.org/drawingml/2006/main">
-            <a:r>
-              <a:t/>
+              <a:t>Treat the GTM community as a pattern library, not an app store.</a:t>
+            </a:r>
+          </a:p>
+          <a:p xmlns:a="http://schemas.openxmlformats.org/drawingml/2006/main">
+            <a:r>
+              <a:t>Read the Level 3 sequence left to right: verify evidence, interpret meaning, qualify the audience, then generate a draft.</a:t>
+            </a:r>
+          </a:p>
+          <a:p xmlns:a="http://schemas.openxmlformats.org/drawingml/2006/main">
+            <a:r>
+              <a:t>Hiring Signal Verification is the evidence gate. The local evaluation passed six adversarial synthetic cases. A live read-only audit of 11 labels accepted 2, narrowed 4, and dropped 5. Verification belongs before scoring or messaging.</a:t>
+            </a:r>
+          </a:p>
+          <a:p xmlns:a="http://schemas.openxmlformats.org/drawingml/2006/main">
+            <a:r>
+              <a:t>Signal Interpreter is a pure interpretation gate. It returns meaning, strength, confidence, why-now, limits, and open questions without routing or writing.</a:t>
+            </a:r>
+          </a:p>
+          <a:p xmlns:a="http://schemas.openxmlformats.org/drawingml/2006/main">
+            <a:r>
+              <a:t>Audience ICP Filter is the qualification gate. A 22-person synthetic fixture reconciled every record into Keep, Exclude, or Review, and the bundled suite passed 45 of 45 checks.</a:t>
+            </a:r>
+          </a:p>
+          <a:p xmlns:a="http://schemas.openxmlformats.org/drawingml/2006/main">
+            <a:r>
+              <a:t>Multichannel Campaign Builder is a conditional draft-generation example. One synthetic brief produced three distinct angles and a five-touch sequence. Require source-backed inputs and human copy QA before any send or activation.</a:t>
+            </a:r>
+          </a:p>
+          <a:p xmlns:a="http://schemas.openxmlformats.org/drawingml/2006/main">
+            <a:r>
+              <a:t>Company Deep Dive is only a Level 2-to-3 source-hierarchy concept. Its evidence is T1 static review, so do not call the package operationally verified.</a:t>
+            </a:r>
+          </a:p>
+          <a:p xmlns:a="http://schemas.openxmlformats.org/drawingml/2006/main">
+            <a:r>
+              <a:t>Do not install or run Swan GTM packages in the live build. Keep the North Peak and Alder path unchanged.</a:t>
             </a:r>
           </a:p>
           <a:p xmlns:a="http://schemas.openxmlformats.org/drawingml/2006/main">
@@ -832,27 +862,37 @@
           </a:p>
           <a:p xmlns:a="http://schemas.openxmlformats.org/drawingml/2006/main">
             <a:r>
-              <a:t>- https://github.com/swan-gtm/gtm-skills/tree/d378356a2668095d71e8dfb0661155255cf6776b/skills/erwann-lefevre/multichannel-campaign-builder</a:t>
-            </a:r>
-          </a:p>
-          <a:p xmlns:a="http://schemas.openxmlformats.org/drawingml/2006/main">
-            <a:r>
-              <a:t>- https://github.com/swan-gtm/gtm-skills/tree/d378356a2668095d71e8dfb0661155255cf6776b/skills/ivan-falco/1-to-1-abm-ads</a:t>
-            </a:r>
-          </a:p>
-          <a:p xmlns:a="http://schemas.openxmlformats.org/drawingml/2006/main">
-            <a:r>
-              <a:t>- https://github.com/swan-gtm/gtm-skills/blob/d378356a2668095d71e8dfb0661155255cf6776b/LICENSE</a:t>
-            </a:r>
-          </a:p>
-          <a:p xmlns:a="http://schemas.openxmlformats.org/drawingml/2006/main">
-            <a:r>
-              <a:t>- /Users/treyharnden/Projects/Folloze-Skills-swan-eval/evaluations/swan-gtm/pilots/audience-icp-filter/sample-evaluation.md at local commit 938b70d760e002a85c5b0a6a83fe395403b98959</a:t>
-            </a:r>
-          </a:p>
-          <a:p xmlns:a="http://schemas.openxmlformats.org/drawingml/2006/main">
-            <a:r>
-              <a:t>- /Users/treyharnden/Projects/forgex-practical-abm-skills/webinar/2026-09-17-ai-for-abm-foundations/sources-and-attribution.md</a:t>
+              <a:t>Swan GTM Skills license: https://github.com/swan-gtm/gtm-skills/blob/d378356a2668095d71e8dfb0661155255cf6776b/LICENSE</a:t>
+            </a:r>
+          </a:p>
+          <a:p xmlns:a="http://schemas.openxmlformats.org/drawingml/2006/main">
+            <a:r>
+              <a:t>Hiring Signal Verification, Peter S. Borkovich: https://github.com/swan-gtm/gtm-skills/tree/d378356a2668095d71e8dfb0661155255cf6776b/skills/peter-borkovich/hiring-signal-verification</a:t>
+            </a:r>
+          </a:p>
+          <a:p xmlns:a="http://schemas.openxmlformats.org/drawingml/2006/main">
+            <a:r>
+              <a:t>Signal Interpreter, Din Arbel: https://github.com/swan-gtm/gtm-skills/tree/d378356a2668095d71e8dfb0661155255cf6776b/skills/din-arbel/signal-interpreter</a:t>
+            </a:r>
+          </a:p>
+          <a:p xmlns:a="http://schemas.openxmlformats.org/drawingml/2006/main">
+            <a:r>
+              <a:t>Audience ICP Filter, Erwann Lefevre: https://github.com/swan-gtm/gtm-skills/tree/d378356a2668095d71e8dfb0661155255cf6776b/skills/erwann-lefevre/audience-icp-filter</a:t>
+            </a:r>
+          </a:p>
+          <a:p xmlns:a="http://schemas.openxmlformats.org/drawingml/2006/main">
+            <a:r>
+              <a:t>Multichannel Campaign Builder, Erwann Lefevre: https://github.com/swan-gtm/gtm-skills/tree/d378356a2668095d71e8dfb0661155255cf6776b/skills/erwann-lefevre/multichannel-campaign-builder</a:t>
+            </a:r>
+          </a:p>
+          <a:p xmlns:a="http://schemas.openxmlformats.org/drawingml/2006/main">
+            <a:r>
+              <a:t>Company Deep Dive, Uriel Knorovich: https://github.com/swan-gtm/gtm-skills/tree/d378356a2668095d71e8dfb0661155255cf6776b/skills/uri-knorovich/company-deep-dive</a:t>
+            </a:r>
+          </a:p>
+          <a:p xmlns:a="http://schemas.openxmlformats.org/drawingml/2006/main">
+            <a:r>
+              <a:t>Local evaluation evidence: /Users/treyharnden/Projects/Folloze-Skills-swan-eval/evaluations/swan-gtm at commit 8dd94e1</a:t>
             </a:r>
           </a:p>
         </p:txBody>
@@ -2320,7 +2360,7 @@
   </p:cSld>
   <p:clrMap bg1="lt1" tx1="dk1" bg2="lt2" tx2="dk2" accent1="accent1" accent2="accent2" accent3="accent3" accent4="accent4" accent5="accent5" accent6="accent6" hlink="hlink" folHlink="folHlink"/>
   <p:sldLayoutIdLst>
-    <p:sldLayoutId xmlns:r="http://schemas.openxmlformats.org/officeDocument/2006/relationships" id="2147483649" r:id="Rbc515e5be2ef4e30"/>
+    <p:sldLayoutId xmlns:r="http://schemas.openxmlformats.org/officeDocument/2006/relationships" id="2147483649" r:id="R2a2ab9de4a4245df"/>
   </p:sldLayoutIdLst>
   <p:txStyles>
     <p:titleStyle>
@@ -2899,6 +2939,7 @@
           <a:lstStyle xmlns:a="http://schemas.openxmlformats.org/drawingml/2006/main"/>
           <a:p xmlns:a="http://schemas.openxmlformats.org/drawingml/2006/main">
             <a:pPr algn="l">
+              <a:buNone/>
               <a:defRPr sz="1800" b="1">
                 <a:solidFill>
                   <a:srgbClr val="E63888"/>
@@ -4220,6 +4261,7 @@
           <a:lstStyle xmlns:a="http://schemas.openxmlformats.org/drawingml/2006/main"/>
           <a:p xmlns:a="http://schemas.openxmlformats.org/drawingml/2006/main">
             <a:pPr algn="l">
+              <a:buNone/>
               <a:defRPr sz="3600" b="1">
                 <a:solidFill>
                   <a:srgbClr val="E63888"/>
@@ -4270,6 +4312,7 @@
           <a:lstStyle xmlns:a="http://schemas.openxmlformats.org/drawingml/2006/main"/>
           <a:p xmlns:a="http://schemas.openxmlformats.org/drawingml/2006/main">
             <a:pPr algn="l">
+              <a:buNone/>
               <a:defRPr sz="4200" b="1">
                 <a:solidFill>
                   <a:srgbClr val="FFFFFF"/>
@@ -4287,6 +4330,7 @@
           </a:p>
           <a:p xmlns:a="http://schemas.openxmlformats.org/drawingml/2006/main">
             <a:pPr algn="l">
+              <a:buNone/>
               <a:defRPr sz="4200" b="1">
                 <a:solidFill>
                   <a:srgbClr val="FFFFFF"/>
@@ -4368,6 +4412,7 @@
           <a:lstStyle xmlns:a="http://schemas.openxmlformats.org/drawingml/2006/main"/>
           <a:p xmlns:a="http://schemas.openxmlformats.org/drawingml/2006/main">
             <a:pPr algn="l">
+              <a:buNone/>
               <a:defRPr sz="1200" b="1">
                 <a:solidFill>
                   <a:srgbClr val="FFFFFF"/>
@@ -4418,6 +4463,7 @@
           <a:lstStyle xmlns:a="http://schemas.openxmlformats.org/drawingml/2006/main"/>
           <a:p xmlns:a="http://schemas.openxmlformats.org/drawingml/2006/main">
             <a:pPr algn="l">
+              <a:buNone/>
               <a:defRPr sz="1050" b="1">
                 <a:solidFill>
                   <a:srgbClr val="C7F25C"/>
@@ -4590,6 +4636,7 @@
           <a:lstStyle xmlns:a="http://schemas.openxmlformats.org/drawingml/2006/main"/>
           <a:p xmlns:a="http://schemas.openxmlformats.org/drawingml/2006/main">
             <a:pPr algn="l">
+              <a:buNone/>
               <a:defRPr sz="1800" b="1">
                 <a:solidFill>
                   <a:srgbClr val="E63888"/>
@@ -4671,6 +4718,7 @@
           <a:lstStyle xmlns:a="http://schemas.openxmlformats.org/drawingml/2006/main"/>
           <a:p xmlns:a="http://schemas.openxmlformats.org/drawingml/2006/main">
             <a:pPr algn="l">
+              <a:buNone/>
               <a:defRPr sz="3150" b="1">
                 <a:solidFill>
                   <a:srgbClr val="FFFFFF"/>
@@ -4721,6 +4769,7 @@
           <a:lstStyle xmlns:a="http://schemas.openxmlformats.org/drawingml/2006/main"/>
           <a:p xmlns:a="http://schemas.openxmlformats.org/drawingml/2006/main">
             <a:pPr algn="l">
+              <a:buNone/>
               <a:defRPr sz="750" b="1">
                 <a:solidFill>
                   <a:srgbClr val="EAE3EC"/>
@@ -4771,6 +4820,7 @@
           <a:lstStyle xmlns:a="http://schemas.openxmlformats.org/drawingml/2006/main"/>
           <a:p xmlns:a="http://schemas.openxmlformats.org/drawingml/2006/main">
             <a:pPr algn="r">
+              <a:buNone/>
               <a:defRPr sz="825" b="1">
                 <a:solidFill>
                   <a:srgbClr val="C7F25C"/>
@@ -4821,6 +4871,7 @@
           <a:lstStyle xmlns:a="http://schemas.openxmlformats.org/drawingml/2006/main"/>
           <a:p xmlns:a="http://schemas.openxmlformats.org/drawingml/2006/main">
             <a:pPr algn="l">
+              <a:buNone/>
               <a:defRPr sz="975" b="1">
                 <a:solidFill>
                   <a:srgbClr val="C7F25C"/>
@@ -4906,6 +4957,7 @@
           <a:lstStyle xmlns:a="http://schemas.openxmlformats.org/drawingml/2006/main"/>
           <a:p xmlns:a="http://schemas.openxmlformats.org/drawingml/2006/main">
             <a:pPr algn="ctr">
+              <a:buNone/>
               <a:defRPr sz="1500" b="1">
                 <a:solidFill>
                   <a:srgbClr val="FFFFFF"/>
@@ -4991,6 +5043,7 @@
           <a:lstStyle xmlns:a="http://schemas.openxmlformats.org/drawingml/2006/main"/>
           <a:p xmlns:a="http://schemas.openxmlformats.org/drawingml/2006/main">
             <a:pPr algn="ctr">
+              <a:buNone/>
               <a:defRPr sz="1500" b="1">
                 <a:solidFill>
                   <a:srgbClr val="FFFFFF"/>
@@ -5076,6 +5129,7 @@
           <a:lstStyle xmlns:a="http://schemas.openxmlformats.org/drawingml/2006/main"/>
           <a:p xmlns:a="http://schemas.openxmlformats.org/drawingml/2006/main">
             <a:pPr algn="ctr">
+              <a:buNone/>
               <a:defRPr sz="1500" b="1">
                 <a:solidFill>
                   <a:srgbClr val="FFFFFF"/>
@@ -5161,6 +5215,7 @@
           <a:lstStyle xmlns:a="http://schemas.openxmlformats.org/drawingml/2006/main"/>
           <a:p xmlns:a="http://schemas.openxmlformats.org/drawingml/2006/main">
             <a:pPr algn="ctr">
+              <a:buNone/>
               <a:defRPr sz="1500" b="1">
                 <a:solidFill>
                   <a:srgbClr val="FFFFFF"/>
@@ -5376,6 +5431,7 @@
           <a:lstStyle xmlns:a="http://schemas.openxmlformats.org/drawingml/2006/main"/>
           <a:p xmlns:a="http://schemas.openxmlformats.org/drawingml/2006/main">
             <a:pPr algn="l">
+              <a:buNone/>
               <a:defRPr sz="975" b="1">
                 <a:solidFill>
                   <a:srgbClr val="C7F25C"/>
@@ -5461,6 +5517,7 @@
           <a:lstStyle xmlns:a="http://schemas.openxmlformats.org/drawingml/2006/main"/>
           <a:p xmlns:a="http://schemas.openxmlformats.org/drawingml/2006/main">
             <a:pPr algn="ctr">
+              <a:buNone/>
               <a:defRPr sz="1350" b="1">
                 <a:solidFill>
                   <a:srgbClr val="FFFFFF"/>
@@ -5546,6 +5603,7 @@
           <a:lstStyle xmlns:a="http://schemas.openxmlformats.org/drawingml/2006/main"/>
           <a:p xmlns:a="http://schemas.openxmlformats.org/drawingml/2006/main">
             <a:pPr algn="ctr">
+              <a:buNone/>
               <a:defRPr sz="1350" b="1">
                 <a:solidFill>
                   <a:srgbClr val="FFFFFF"/>
@@ -5631,6 +5689,7 @@
           <a:lstStyle xmlns:a="http://schemas.openxmlformats.org/drawingml/2006/main"/>
           <a:p xmlns:a="http://schemas.openxmlformats.org/drawingml/2006/main">
             <a:pPr algn="ctr">
+              <a:buNone/>
               <a:defRPr sz="1350" b="1">
                 <a:solidFill>
                   <a:srgbClr val="FFFFFF"/>
@@ -5716,6 +5775,7 @@
           <a:lstStyle xmlns:a="http://schemas.openxmlformats.org/drawingml/2006/main"/>
           <a:p xmlns:a="http://schemas.openxmlformats.org/drawingml/2006/main">
             <a:pPr algn="ctr">
+              <a:buNone/>
               <a:defRPr sz="1350" b="1">
                 <a:solidFill>
                   <a:srgbClr val="FFFFFF"/>
@@ -5801,6 +5861,7 @@
           <a:lstStyle xmlns:a="http://schemas.openxmlformats.org/drawingml/2006/main"/>
           <a:p xmlns:a="http://schemas.openxmlformats.org/drawingml/2006/main">
             <a:pPr algn="ctr">
+              <a:buNone/>
               <a:defRPr sz="1350" b="1">
                 <a:solidFill>
                   <a:srgbClr val="FFFFFF"/>
@@ -5851,6 +5912,7 @@
           <a:lstStyle xmlns:a="http://schemas.openxmlformats.org/drawingml/2006/main"/>
           <a:p xmlns:a="http://schemas.openxmlformats.org/drawingml/2006/main">
             <a:pPr algn="ctr">
+              <a:buNone/>
               <a:defRPr sz="1800" b="1">
                 <a:solidFill>
                   <a:srgbClr val="C7F25C"/>
@@ -5930,6 +5992,7 @@
           <a:lstStyle xmlns:a="http://schemas.openxmlformats.org/drawingml/2006/main"/>
           <a:p xmlns:a="http://schemas.openxmlformats.org/drawingml/2006/main">
             <a:pPr algn="l">
+              <a:buNone/>
               <a:defRPr sz="1800" b="1">
                 <a:solidFill>
                   <a:srgbClr val="E63888"/>
@@ -6011,6 +6074,7 @@
           <a:lstStyle xmlns:a="http://schemas.openxmlformats.org/drawingml/2006/main"/>
           <a:p xmlns:a="http://schemas.openxmlformats.org/drawingml/2006/main">
             <a:pPr algn="l">
+              <a:buNone/>
               <a:defRPr sz="3150" b="1">
                 <a:solidFill>
                   <a:srgbClr val="26232A"/>
@@ -6061,6 +6125,7 @@
           <a:lstStyle xmlns:a="http://schemas.openxmlformats.org/drawingml/2006/main"/>
           <a:p xmlns:a="http://schemas.openxmlformats.org/drawingml/2006/main">
             <a:pPr algn="l">
+              <a:buNone/>
               <a:defRPr sz="750" b="1">
                 <a:solidFill>
                   <a:srgbClr val="6E6873"/>
@@ -6111,6 +6176,7 @@
           <a:lstStyle xmlns:a="http://schemas.openxmlformats.org/drawingml/2006/main"/>
           <a:p xmlns:a="http://schemas.openxmlformats.org/drawingml/2006/main">
             <a:pPr algn="r">
+              <a:buNone/>
               <a:defRPr sz="825" b="1">
                 <a:solidFill>
                   <a:srgbClr val="E63888"/>
@@ -6161,6 +6227,7 @@
           <a:lstStyle xmlns:a="http://schemas.openxmlformats.org/drawingml/2006/main"/>
           <a:p xmlns:a="http://schemas.openxmlformats.org/drawingml/2006/main">
             <a:pPr algn="l">
+              <a:buNone/>
               <a:defRPr sz="2100" b="1">
                 <a:solidFill>
                   <a:srgbClr val="6E6873"/>
@@ -6211,6 +6278,7 @@
           <a:lstStyle xmlns:a="http://schemas.openxmlformats.org/drawingml/2006/main"/>
           <a:p xmlns:a="http://schemas.openxmlformats.org/drawingml/2006/main">
             <a:pPr algn="ctr">
+              <a:buNone/>
               <a:defRPr sz="2850" b="1">
                 <a:solidFill>
                   <a:srgbClr val="E63888"/>
@@ -6261,6 +6329,7 @@
           <a:lstStyle xmlns:a="http://schemas.openxmlformats.org/drawingml/2006/main"/>
           <a:p xmlns:a="http://schemas.openxmlformats.org/drawingml/2006/main">
             <a:pPr algn="l">
+              <a:buNone/>
               <a:defRPr sz="2400" b="1">
                 <a:solidFill>
                   <a:srgbClr val="3D1F5C"/>
@@ -6278,6 +6347,7 @@
           </a:p>
           <a:p xmlns:a="http://schemas.openxmlformats.org/drawingml/2006/main">
             <a:pPr algn="l">
+              <a:buNone/>
               <a:defRPr sz="2400" b="1">
                 <a:solidFill>
                   <a:srgbClr val="3D1F5C"/>
@@ -6363,6 +6433,7 @@
           <a:lstStyle xmlns:a="http://schemas.openxmlformats.org/drawingml/2006/main"/>
           <a:p xmlns:a="http://schemas.openxmlformats.org/drawingml/2006/main">
             <a:pPr algn="l">
+              <a:buNone/>
               <a:defRPr sz="975" b="1">
                 <a:solidFill>
                   <a:srgbClr val="E63888"/>
@@ -6413,6 +6484,7 @@
           <a:lstStyle xmlns:a="http://schemas.openxmlformats.org/drawingml/2006/main"/>
           <a:p xmlns:a="http://schemas.openxmlformats.org/drawingml/2006/main">
             <a:pPr algn="l">
+              <a:buNone/>
               <a:defRPr sz="1425" b="0">
                 <a:solidFill>
                   <a:srgbClr val="26232A"/>
@@ -6496,6 +6568,7 @@
           <a:lstStyle xmlns:a="http://schemas.openxmlformats.org/drawingml/2006/main"/>
           <a:p xmlns:a="http://schemas.openxmlformats.org/drawingml/2006/main">
             <a:pPr algn="l">
+              <a:buNone/>
               <a:defRPr sz="975" b="1">
                 <a:solidFill>
                   <a:srgbClr val="C7F25C"/>
@@ -6546,6 +6619,7 @@
           <a:lstStyle xmlns:a="http://schemas.openxmlformats.org/drawingml/2006/main"/>
           <a:p xmlns:a="http://schemas.openxmlformats.org/drawingml/2006/main">
             <a:pPr algn="l">
+              <a:buNone/>
               <a:defRPr sz="1650" b="1">
                 <a:solidFill>
                   <a:srgbClr val="FFFFFF"/>
@@ -6629,6 +6703,7 @@
           <a:lstStyle xmlns:a="http://schemas.openxmlformats.org/drawingml/2006/main"/>
           <a:p xmlns:a="http://schemas.openxmlformats.org/drawingml/2006/main">
             <a:pPr algn="l">
+              <a:buNone/>
               <a:defRPr sz="975" b="1">
                 <a:solidFill>
                   <a:srgbClr val="3D1F5C"/>
@@ -6679,6 +6754,7 @@
           <a:lstStyle xmlns:a="http://schemas.openxmlformats.org/drawingml/2006/main"/>
           <a:p xmlns:a="http://schemas.openxmlformats.org/drawingml/2006/main">
             <a:pPr algn="l">
+              <a:buNone/>
               <a:defRPr sz="1350" b="1">
                 <a:solidFill>
                   <a:srgbClr val="3D1F5C"/>
@@ -6758,6 +6834,7 @@
           <a:lstStyle xmlns:a="http://schemas.openxmlformats.org/drawingml/2006/main"/>
           <a:p xmlns:a="http://schemas.openxmlformats.org/drawingml/2006/main">
             <a:pPr algn="l">
+              <a:buNone/>
               <a:defRPr sz="1800" b="1">
                 <a:solidFill>
                   <a:srgbClr val="E63888"/>
@@ -6839,6 +6916,7 @@
           <a:lstStyle xmlns:a="http://schemas.openxmlformats.org/drawingml/2006/main"/>
           <a:p xmlns:a="http://schemas.openxmlformats.org/drawingml/2006/main">
             <a:pPr algn="l">
+              <a:buNone/>
               <a:defRPr sz="3150" b="1">
                 <a:solidFill>
                   <a:srgbClr val="FFFFFF"/>
@@ -6889,6 +6967,7 @@
           <a:lstStyle xmlns:a="http://schemas.openxmlformats.org/drawingml/2006/main"/>
           <a:p xmlns:a="http://schemas.openxmlformats.org/drawingml/2006/main">
             <a:pPr algn="l">
+              <a:buNone/>
               <a:defRPr sz="750" b="1">
                 <a:solidFill>
                   <a:srgbClr val="EAE3EC"/>
@@ -6939,6 +7018,7 @@
           <a:lstStyle xmlns:a="http://schemas.openxmlformats.org/drawingml/2006/main"/>
           <a:p xmlns:a="http://schemas.openxmlformats.org/drawingml/2006/main">
             <a:pPr algn="r">
+              <a:buNone/>
               <a:defRPr sz="825" b="1">
                 <a:solidFill>
                   <a:srgbClr val="C7F25C"/>
@@ -7024,6 +7104,7 @@
           <a:lstStyle xmlns:a="http://schemas.openxmlformats.org/drawingml/2006/main"/>
           <a:p xmlns:a="http://schemas.openxmlformats.org/drawingml/2006/main">
             <a:pPr algn="l">
+              <a:buNone/>
               <a:defRPr sz="1050" b="1">
                 <a:solidFill>
                   <a:srgbClr val="C7F25C"/>
@@ -7074,6 +7155,7 @@
           <a:lstStyle xmlns:a="http://schemas.openxmlformats.org/drawingml/2006/main"/>
           <a:p xmlns:a="http://schemas.openxmlformats.org/drawingml/2006/main">
             <a:pPr algn="ctr">
+              <a:buNone/>
               <a:defRPr sz="1350" b="1">
                 <a:solidFill>
                   <a:srgbClr val="FFFFFF"/>
@@ -7124,6 +7206,7 @@
           <a:lstStyle xmlns:a="http://schemas.openxmlformats.org/drawingml/2006/main"/>
           <a:p xmlns:a="http://schemas.openxmlformats.org/drawingml/2006/main">
             <a:pPr algn="ctr">
+              <a:buNone/>
               <a:defRPr sz="1650" b="1">
                 <a:solidFill>
                   <a:srgbClr val="E63888"/>
@@ -7209,6 +7292,7 @@
           <a:lstStyle xmlns:a="http://schemas.openxmlformats.org/drawingml/2006/main"/>
           <a:p xmlns:a="http://schemas.openxmlformats.org/drawingml/2006/main">
             <a:pPr algn="l">
+              <a:buNone/>
               <a:defRPr sz="1050" b="1">
                 <a:solidFill>
                   <a:srgbClr val="C7F25C"/>
@@ -7259,6 +7343,7 @@
           <a:lstStyle xmlns:a="http://schemas.openxmlformats.org/drawingml/2006/main"/>
           <a:p xmlns:a="http://schemas.openxmlformats.org/drawingml/2006/main">
             <a:pPr algn="ctr">
+              <a:buNone/>
               <a:defRPr sz="1350" b="1">
                 <a:solidFill>
                   <a:srgbClr val="FFFFFF"/>
@@ -7309,6 +7394,7 @@
           <a:lstStyle xmlns:a="http://schemas.openxmlformats.org/drawingml/2006/main"/>
           <a:p xmlns:a="http://schemas.openxmlformats.org/drawingml/2006/main">
             <a:pPr algn="ctr">
+              <a:buNone/>
               <a:defRPr sz="1650" b="1">
                 <a:solidFill>
                   <a:srgbClr val="E63888"/>
@@ -7394,6 +7480,7 @@
           <a:lstStyle xmlns:a="http://schemas.openxmlformats.org/drawingml/2006/main"/>
           <a:p xmlns:a="http://schemas.openxmlformats.org/drawingml/2006/main">
             <a:pPr algn="l">
+              <a:buNone/>
               <a:defRPr sz="1050" b="1">
                 <a:solidFill>
                   <a:srgbClr val="C7F25C"/>
@@ -7444,6 +7531,7 @@
           <a:lstStyle xmlns:a="http://schemas.openxmlformats.org/drawingml/2006/main"/>
           <a:p xmlns:a="http://schemas.openxmlformats.org/drawingml/2006/main">
             <a:pPr algn="ctr">
+              <a:buNone/>
               <a:defRPr sz="1350" b="1">
                 <a:solidFill>
                   <a:srgbClr val="FFFFFF"/>
@@ -7494,6 +7582,7 @@
           <a:lstStyle xmlns:a="http://schemas.openxmlformats.org/drawingml/2006/main"/>
           <a:p xmlns:a="http://schemas.openxmlformats.org/drawingml/2006/main">
             <a:pPr algn="ctr">
+              <a:buNone/>
               <a:defRPr sz="1650" b="1">
                 <a:solidFill>
                   <a:srgbClr val="E63888"/>
@@ -7579,6 +7668,7 @@
           <a:lstStyle xmlns:a="http://schemas.openxmlformats.org/drawingml/2006/main"/>
           <a:p xmlns:a="http://schemas.openxmlformats.org/drawingml/2006/main">
             <a:pPr algn="l">
+              <a:buNone/>
               <a:defRPr sz="1050" b="1">
                 <a:solidFill>
                   <a:srgbClr val="C7F25C"/>
@@ -7629,6 +7719,7 @@
           <a:lstStyle xmlns:a="http://schemas.openxmlformats.org/drawingml/2006/main"/>
           <a:p xmlns:a="http://schemas.openxmlformats.org/drawingml/2006/main">
             <a:pPr algn="ctr">
+              <a:buNone/>
               <a:defRPr sz="1350" b="1">
                 <a:solidFill>
                   <a:srgbClr val="FFFFFF"/>
@@ -7679,6 +7770,7 @@
           <a:lstStyle xmlns:a="http://schemas.openxmlformats.org/drawingml/2006/main"/>
           <a:p xmlns:a="http://schemas.openxmlformats.org/drawingml/2006/main">
             <a:pPr algn="ctr">
+              <a:buNone/>
               <a:defRPr sz="1650" b="1">
                 <a:solidFill>
                   <a:srgbClr val="E63888"/>
@@ -7764,6 +7856,7 @@
           <a:lstStyle xmlns:a="http://schemas.openxmlformats.org/drawingml/2006/main"/>
           <a:p xmlns:a="http://schemas.openxmlformats.org/drawingml/2006/main">
             <a:pPr algn="l">
+              <a:buNone/>
               <a:defRPr sz="1050" b="1">
                 <a:solidFill>
                   <a:srgbClr val="C7F25C"/>
@@ -7814,6 +7907,7 @@
           <a:lstStyle xmlns:a="http://schemas.openxmlformats.org/drawingml/2006/main"/>
           <a:p xmlns:a="http://schemas.openxmlformats.org/drawingml/2006/main">
             <a:pPr algn="ctr">
+              <a:buNone/>
               <a:defRPr sz="1350" b="1">
                 <a:solidFill>
                   <a:srgbClr val="FFFFFF"/>
@@ -7864,6 +7958,7 @@
           <a:lstStyle xmlns:a="http://schemas.openxmlformats.org/drawingml/2006/main"/>
           <a:p xmlns:a="http://schemas.openxmlformats.org/drawingml/2006/main">
             <a:pPr algn="ctr">
+              <a:buNone/>
               <a:defRPr sz="1650" b="1">
                 <a:solidFill>
                   <a:srgbClr val="E63888"/>
@@ -7949,6 +8044,7 @@
           <a:lstStyle xmlns:a="http://schemas.openxmlformats.org/drawingml/2006/main"/>
           <a:p xmlns:a="http://schemas.openxmlformats.org/drawingml/2006/main">
             <a:pPr algn="l">
+              <a:buNone/>
               <a:defRPr sz="1050" b="1">
                 <a:solidFill>
                   <a:srgbClr val="C7F25C"/>
@@ -7999,6 +8095,7 @@
           <a:lstStyle xmlns:a="http://schemas.openxmlformats.org/drawingml/2006/main"/>
           <a:p xmlns:a="http://schemas.openxmlformats.org/drawingml/2006/main">
             <a:pPr algn="ctr">
+              <a:buNone/>
               <a:defRPr sz="1350" b="1">
                 <a:solidFill>
                   <a:srgbClr val="FFFFFF"/>
@@ -8049,6 +8146,7 @@
           <a:lstStyle xmlns:a="http://schemas.openxmlformats.org/drawingml/2006/main"/>
           <a:p xmlns:a="http://schemas.openxmlformats.org/drawingml/2006/main">
             <a:pPr algn="ctr">
+              <a:buNone/>
               <a:defRPr sz="1950" b="1">
                 <a:solidFill>
                   <a:srgbClr val="FFFFFF"/>
@@ -8099,6 +8197,7 @@
           <a:lstStyle xmlns:a="http://schemas.openxmlformats.org/drawingml/2006/main"/>
           <a:p xmlns:a="http://schemas.openxmlformats.org/drawingml/2006/main">
             <a:pPr algn="ctr">
+              <a:buNone/>
               <a:defRPr sz="1575" b="1">
                 <a:solidFill>
                   <a:srgbClr val="C7F25C"/>
@@ -8178,6 +8277,7 @@
           <a:lstStyle xmlns:a="http://schemas.openxmlformats.org/drawingml/2006/main"/>
           <a:p xmlns:a="http://schemas.openxmlformats.org/drawingml/2006/main">
             <a:pPr algn="l">
+              <a:buNone/>
               <a:defRPr sz="1800" b="1">
                 <a:solidFill>
                   <a:srgbClr val="E63888"/>
@@ -8259,6 +8359,7 @@
           <a:lstStyle xmlns:a="http://schemas.openxmlformats.org/drawingml/2006/main"/>
           <a:p xmlns:a="http://schemas.openxmlformats.org/drawingml/2006/main">
             <a:pPr algn="l">
+              <a:buNone/>
               <a:defRPr sz="3150" b="1">
                 <a:solidFill>
                   <a:srgbClr val="26232A"/>
@@ -8271,7 +8372,7 @@
                   <a:srgbClr val="26232A"/>
                 </a:solidFill>
               </a:rPr>
-              <a:t>Borrow the pattern. Keep the attribution.</a:t>
+              <a:t>Verify, interpret, qualify, then draft.</a:t>
             </a:r>
           </a:p>
         </p:txBody>
@@ -8309,6 +8410,7 @@
           <a:lstStyle xmlns:a="http://schemas.openxmlformats.org/drawingml/2006/main"/>
           <a:p xmlns:a="http://schemas.openxmlformats.org/drawingml/2006/main">
             <a:pPr algn="l">
+              <a:buNone/>
               <a:defRPr sz="750" b="1">
                 <a:solidFill>
                   <a:srgbClr val="6E6873"/>
@@ -8359,6 +8461,7 @@
           <a:lstStyle xmlns:a="http://schemas.openxmlformats.org/drawingml/2006/main"/>
           <a:p xmlns:a="http://schemas.openxmlformats.org/drawingml/2006/main">
             <a:pPr algn="r">
+              <a:buNone/>
               <a:defRPr sz="825" b="1">
                 <a:solidFill>
                   <a:srgbClr val="E63888"/>
@@ -8444,6 +8547,7 @@
           <a:lstStyle xmlns:a="http://schemas.openxmlformats.org/drawingml/2006/main"/>
           <a:p xmlns:a="http://schemas.openxmlformats.org/drawingml/2006/main">
             <a:pPr algn="l">
+              <a:buNone/>
               <a:defRPr sz="1500" b="1">
                 <a:solidFill>
                   <a:srgbClr val="3D1F5C"/>
@@ -8456,7 +8560,7 @@
                   <a:srgbClr val="3D1F5C"/>
                 </a:solidFill>
               </a:rPr>
-              <a:t>MULTICHANNEL CAMPAIGN BUILDER</a:t>
+              <a:t>1 VERIFY | HIRING SIGNAL VERIFICATION</a:t>
             </a:r>
           </a:p>
         </p:txBody>
@@ -8494,6 +8598,7 @@
           <a:lstStyle xmlns:a="http://schemas.openxmlformats.org/drawingml/2006/main"/>
           <a:p xmlns:a="http://schemas.openxmlformats.org/drawingml/2006/main">
             <a:pPr algn="l">
+              <a:buNone/>
               <a:defRPr sz="1050" b="1">
                 <a:solidFill>
                   <a:srgbClr val="E63888"/>
@@ -8506,7 +8611,7 @@
                   <a:srgbClr val="E63888"/>
                 </a:solidFill>
               </a:rPr>
-              <a:t>Erwann Lefevre  |  Level 3</a:t>
+              <a:t>Peter S. Borkovich | T3 synthetic + T4 live read-only</a:t>
             </a:r>
           </a:p>
         </p:txBody>
@@ -8544,6 +8649,7 @@
           <a:lstStyle xmlns:a="http://schemas.openxmlformats.org/drawingml/2006/main"/>
           <a:p xmlns:a="http://schemas.openxmlformats.org/drawingml/2006/main">
             <a:pPr algn="l">
+              <a:buNone/>
               <a:defRPr sz="1275" b="0">
                 <a:solidFill>
                   <a:srgbClr val="26232A"/>
@@ -8556,7 +8662,8 @@
                   <a:srgbClr val="26232A"/>
                 </a:solidFill>
               </a:rPr>
-              <a:t>intake → 3 angles → correction → channel rules → output → QA</a:t>
+              <a:t>2 INTERPRET | Signal Interpreter | Din Arbel
+T3 synthetic | meaning + confidence + why-now | no routing or writes</a:t>
             </a:r>
           </a:p>
         </p:txBody>
@@ -8629,6 +8736,7 @@
           <a:lstStyle xmlns:a="http://schemas.openxmlformats.org/drawingml/2006/main"/>
           <a:p xmlns:a="http://schemas.openxmlformats.org/drawingml/2006/main">
             <a:pPr algn="l">
+              <a:buNone/>
               <a:defRPr sz="1500" b="1">
                 <a:solidFill>
                   <a:srgbClr val="FFFFFF"/>
@@ -8641,7 +8749,7 @@
                   <a:srgbClr val="FFFFFF"/>
                 </a:solidFill>
               </a:rPr>
-              <a:t>1:1 ABM ADS</a:t>
+              <a:t>3 QUALIFY | AUDIENCE ICP FILTER</a:t>
             </a:r>
           </a:p>
         </p:txBody>
@@ -8679,6 +8787,7 @@
           <a:lstStyle xmlns:a="http://schemas.openxmlformats.org/drawingml/2006/main"/>
           <a:p xmlns:a="http://schemas.openxmlformats.org/drawingml/2006/main">
             <a:pPr algn="l">
+              <a:buNone/>
               <a:defRPr sz="1050" b="1">
                 <a:solidFill>
                   <a:srgbClr val="C7F25C"/>
@@ -8691,7 +8800,7 @@
                   <a:srgbClr val="C7F25C"/>
                 </a:solidFill>
               </a:rPr>
-              <a:t>Ivan Falco  |  Advanced Level 3 to 4</a:t>
+              <a:t>Erwann Lefevre | T3 synthetic | Keep / Exclude / Review</a:t>
             </a:r>
           </a:p>
         </p:txBody>
@@ -8729,6 +8838,7 @@
           <a:lstStyle xmlns:a="http://schemas.openxmlformats.org/drawingml/2006/main"/>
           <a:p xmlns:a="http://schemas.openxmlformats.org/drawingml/2006/main">
             <a:pPr algn="l">
+              <a:buNone/>
               <a:defRPr sz="1275" b="0">
                 <a:solidFill>
                   <a:srgbClr val="FFFFFF"/>
@@ -8741,7 +8851,8 @@
                   <a:srgbClr val="FFFFFF"/>
                 </a:solidFill>
               </a:rPr>
-              <a:t>SOPs → scripts → DRAFT creation → QA → explicit activation gate</a:t>
+              <a:t>4 DRAFT | Multichannel Campaign Builder | Erwann Lefevre
+T3 conditional synthetic | source-backed inputs + mandatory human QA</a:t>
             </a:r>
           </a:p>
         </p:txBody>
@@ -8779,6 +8890,7 @@
           <a:lstStyle xmlns:a="http://schemas.openxmlformats.org/drawingml/2006/main"/>
           <a:p xmlns:a="http://schemas.openxmlformats.org/drawingml/2006/main">
             <a:pPr algn="l">
+              <a:buNone/>
               <a:defRPr sz="975" b="1">
                 <a:solidFill>
                   <a:srgbClr val="E63888"/>
@@ -8791,7 +8903,7 @@
                   <a:srgbClr val="E63888"/>
                 </a:solidFill>
               </a:rPr>
-              <a:t>ADOPT OR PILOT PATTERNS</a:t>
+              <a:t>LEVEL 2 TO 3 SOURCE BRIDGE</a:t>
             </a:r>
           </a:p>
         </p:txBody>
@@ -8829,6 +8941,7 @@
           <a:lstStyle xmlns:a="http://schemas.openxmlformats.org/drawingml/2006/main"/>
           <a:p xmlns:a="http://schemas.openxmlformats.org/drawingml/2006/main">
             <a:pPr algn="ctr">
+              <a:buNone/>
               <a:defRPr sz="1275" b="1">
                 <a:solidFill>
                   <a:srgbClr val="3D1F5C"/>
@@ -8841,7 +8954,7 @@
                   <a:srgbClr val="3D1F5C"/>
                 </a:solidFill>
               </a:rPr>
-              <a:t>Hiring verification  •  Signal interpretation  •  ICP reconciliation  •  Dated company research</a:t>
+              <a:t>Company Deep Dive | Uriel Knorovich | T1 static only | source hierarchy, dated claims, contradictions, refresh deduplication</a:t>
             </a:r>
           </a:p>
         </p:txBody>
@@ -8912,6 +9025,7 @@
           <a:lstStyle xmlns:a="http://schemas.openxmlformats.org/drawingml/2006/main"/>
           <a:p xmlns:a="http://schemas.openxmlformats.org/drawingml/2006/main">
             <a:pPr algn="ctr">
+              <a:buNone/>
               <a:defRPr sz="1050" b="1">
                 <a:solidFill>
                   <a:srgbClr val="3D1F5C"/>
@@ -8924,7 +9038,7 @@
                   <a:srgbClr val="3D1F5C"/>
                 </a:solidFill>
               </a:rPr>
-              <a:t>AUDIENCE FILTER: 22 reconciled  |  9 semantic review  |  final 12 match, 1 review, 6 no match, 3 excluded  |  45/45</a:t>
+              <a:t>22 ICP records reconciled | 45/45 checks | hiring audit: 2 accepted, 4 narrowed, 5 dropped</a:t>
             </a:r>
           </a:p>
         </p:txBody>
@@ -8962,6 +9076,7 @@
           <a:lstStyle xmlns:a="http://schemas.openxmlformats.org/drawingml/2006/main"/>
           <a:p xmlns:a="http://schemas.openxmlformats.org/drawingml/2006/main">
             <a:pPr algn="ctr">
+              <a:buNone/>
               <a:defRPr sz="825" b="0">
                 <a:solidFill>
                   <a:srgbClr val="6E6873"/>
@@ -8974,7 +9089,7 @@
                   <a:srgbClr val="6E6873"/>
                 </a:solidFill>
               </a:rPr>
-              <a:t>Conditional pass for reviewed list classification only. No enrichment, sending, CRM writes, or sequence enrollment.</a:t>
+              <a:t>External community work. Teaching references only. No Swan packages in the live build or external actions from these examples.</a:t>
             </a:r>
           </a:p>
         </p:txBody>
@@ -9041,6 +9156,7 @@
           <a:lstStyle xmlns:a="http://schemas.openxmlformats.org/drawingml/2006/main"/>
           <a:p xmlns:a="http://schemas.openxmlformats.org/drawingml/2006/main">
             <a:pPr algn="l">
+              <a:buNone/>
               <a:defRPr sz="1800" b="1">
                 <a:solidFill>
                   <a:srgbClr val="E63888"/>
@@ -9122,6 +9238,7 @@
           <a:lstStyle xmlns:a="http://schemas.openxmlformats.org/drawingml/2006/main"/>
           <a:p xmlns:a="http://schemas.openxmlformats.org/drawingml/2006/main">
             <a:pPr algn="l">
+              <a:buNone/>
               <a:defRPr sz="3150" b="1">
                 <a:solidFill>
                   <a:srgbClr val="26232A"/>
@@ -9172,6 +9289,7 @@
           <a:lstStyle xmlns:a="http://schemas.openxmlformats.org/drawingml/2006/main"/>
           <a:p xmlns:a="http://schemas.openxmlformats.org/drawingml/2006/main">
             <a:pPr algn="l">
+              <a:buNone/>
               <a:defRPr sz="750" b="1">
                 <a:solidFill>
                   <a:srgbClr val="6E6873"/>
@@ -9222,6 +9340,7 @@
           <a:lstStyle xmlns:a="http://schemas.openxmlformats.org/drawingml/2006/main"/>
           <a:p xmlns:a="http://schemas.openxmlformats.org/drawingml/2006/main">
             <a:pPr algn="r">
+              <a:buNone/>
               <a:defRPr sz="825" b="1">
                 <a:solidFill>
                   <a:srgbClr val="E63888"/>
@@ -9307,6 +9426,7 @@
           <a:lstStyle xmlns:a="http://schemas.openxmlformats.org/drawingml/2006/main"/>
           <a:p xmlns:a="http://schemas.openxmlformats.org/drawingml/2006/main">
             <a:pPr algn="l">
+              <a:buNone/>
               <a:defRPr sz="975" b="1">
                 <a:solidFill>
                   <a:srgbClr val="E63888"/>
@@ -9357,6 +9477,7 @@
           <a:lstStyle xmlns:a="http://schemas.openxmlformats.org/drawingml/2006/main"/>
           <a:p xmlns:a="http://schemas.openxmlformats.org/drawingml/2006/main">
             <a:pPr algn="l">
+              <a:buNone/>
               <a:defRPr sz="1425" b="0">
                 <a:solidFill>
                   <a:srgbClr val="26232A"/>
@@ -9440,6 +9561,7 @@
           <a:lstStyle xmlns:a="http://schemas.openxmlformats.org/drawingml/2006/main"/>
           <a:p xmlns:a="http://schemas.openxmlformats.org/drawingml/2006/main">
             <a:pPr algn="l">
+              <a:buNone/>
               <a:defRPr sz="975" b="1">
                 <a:solidFill>
                   <a:srgbClr val="C7F25C"/>
@@ -9490,6 +9612,7 @@
           <a:lstStyle xmlns:a="http://schemas.openxmlformats.org/drawingml/2006/main"/>
           <a:p xmlns:a="http://schemas.openxmlformats.org/drawingml/2006/main">
             <a:pPr algn="l">
+              <a:buNone/>
               <a:defRPr sz="1650" b="1">
                 <a:solidFill>
                   <a:srgbClr val="FFFFFF"/>
@@ -9507,6 +9630,7 @@
           </a:p>
           <a:p xmlns:a="http://schemas.openxmlformats.org/drawingml/2006/main">
             <a:pPr algn="l">
+              <a:buNone/>
               <a:defRPr sz="1650" b="1">
                 <a:solidFill>
                   <a:srgbClr val="FFFFFF"/>
@@ -9524,6 +9648,7 @@
           </a:p>
           <a:p xmlns:a="http://schemas.openxmlformats.org/drawingml/2006/main">
             <a:pPr algn="l">
+              <a:buNone/>
               <a:defRPr sz="1650" b="1">
                 <a:solidFill>
                   <a:srgbClr val="FFFFFF"/>
@@ -9541,6 +9666,7 @@
           </a:p>
           <a:p xmlns:a="http://schemas.openxmlformats.org/drawingml/2006/main">
             <a:pPr algn="l">
+              <a:buNone/>
               <a:defRPr sz="1650" b="1">
                 <a:solidFill>
                   <a:srgbClr val="FFFFFF"/>
@@ -9558,6 +9684,7 @@
           </a:p>
           <a:p xmlns:a="http://schemas.openxmlformats.org/drawingml/2006/main">
             <a:pPr algn="l">
+              <a:buNone/>
               <a:defRPr sz="1650" b="1">
                 <a:solidFill>
                   <a:srgbClr val="FFFFFF"/>
@@ -9608,6 +9735,7 @@
           <a:lstStyle xmlns:a="http://schemas.openxmlformats.org/drawingml/2006/main"/>
           <a:p xmlns:a="http://schemas.openxmlformats.org/drawingml/2006/main">
             <a:pPr algn="ctr">
+              <a:buNone/>
               <a:defRPr sz="1875" b="1">
                 <a:solidFill>
                   <a:srgbClr val="3D1F5C"/>
@@ -9691,6 +9819,7 @@
           <a:lstStyle xmlns:a="http://schemas.openxmlformats.org/drawingml/2006/main"/>
           <a:p xmlns:a="http://schemas.openxmlformats.org/drawingml/2006/main">
             <a:pPr algn="l">
+              <a:buNone/>
               <a:defRPr sz="975" b="1">
                 <a:solidFill>
                   <a:srgbClr val="3D1F5C"/>
@@ -9741,6 +9870,7 @@
           <a:lstStyle xmlns:a="http://schemas.openxmlformats.org/drawingml/2006/main"/>
           <a:p xmlns:a="http://schemas.openxmlformats.org/drawingml/2006/main">
             <a:pPr algn="l">
+              <a:buNone/>
               <a:defRPr sz="1350" b="1">
                 <a:solidFill>
                   <a:srgbClr val="3D1F5C"/>
@@ -9820,6 +9950,7 @@
           <a:lstStyle xmlns:a="http://schemas.openxmlformats.org/drawingml/2006/main"/>
           <a:p xmlns:a="http://schemas.openxmlformats.org/drawingml/2006/main">
             <a:pPr algn="l">
+              <a:buNone/>
               <a:defRPr sz="1800" b="1">
                 <a:solidFill>
                   <a:srgbClr val="E63888"/>
@@ -9901,6 +10032,7 @@
           <a:lstStyle xmlns:a="http://schemas.openxmlformats.org/drawingml/2006/main"/>
           <a:p xmlns:a="http://schemas.openxmlformats.org/drawingml/2006/main">
             <a:pPr algn="l">
+              <a:buNone/>
               <a:defRPr sz="3150" b="1">
                 <a:solidFill>
                   <a:srgbClr val="FFFFFF"/>
@@ -9951,6 +10083,7 @@
           <a:lstStyle xmlns:a="http://schemas.openxmlformats.org/drawingml/2006/main"/>
           <a:p xmlns:a="http://schemas.openxmlformats.org/drawingml/2006/main">
             <a:pPr algn="l">
+              <a:buNone/>
               <a:defRPr sz="750" b="1">
                 <a:solidFill>
                   <a:srgbClr val="EAE3EC"/>
@@ -10001,6 +10134,7 @@
           <a:lstStyle xmlns:a="http://schemas.openxmlformats.org/drawingml/2006/main"/>
           <a:p xmlns:a="http://schemas.openxmlformats.org/drawingml/2006/main">
             <a:pPr algn="r">
+              <a:buNone/>
               <a:defRPr sz="825" b="1">
                 <a:solidFill>
                   <a:srgbClr val="C7F25C"/>
@@ -10051,6 +10185,7 @@
           <a:lstStyle xmlns:a="http://schemas.openxmlformats.org/drawingml/2006/main"/>
           <a:p xmlns:a="http://schemas.openxmlformats.org/drawingml/2006/main">
             <a:pPr algn="l">
+              <a:buNone/>
               <a:defRPr sz="2550" b="1">
                 <a:solidFill>
                   <a:srgbClr val="FFFFFF"/>
@@ -10068,6 +10203,7 @@
           </a:p>
           <a:p xmlns:a="http://schemas.openxmlformats.org/drawingml/2006/main">
             <a:pPr algn="l">
+              <a:buNone/>
               <a:defRPr sz="2550" b="1">
                 <a:solidFill>
                   <a:srgbClr val="FFFFFF"/>
@@ -10118,6 +10254,7 @@
           <a:lstStyle xmlns:a="http://schemas.openxmlformats.org/drawingml/2006/main"/>
           <a:p xmlns:a="http://schemas.openxmlformats.org/drawingml/2006/main">
             <a:pPr algn="l">
+              <a:buNone/>
               <a:defRPr sz="975" b="1">
                 <a:solidFill>
                   <a:srgbClr val="C7F25C"/>
@@ -10168,6 +10305,7 @@
           <a:lstStyle xmlns:a="http://schemas.openxmlformats.org/drawingml/2006/main"/>
           <a:p xmlns:a="http://schemas.openxmlformats.org/drawingml/2006/main">
             <a:pPr algn="l">
+              <a:buNone/>
               <a:defRPr sz="1650" b="0">
                 <a:solidFill>
                   <a:srgbClr val="EAE3EC"/>
@@ -10218,6 +10356,7 @@
           <a:lstStyle xmlns:a="http://schemas.openxmlformats.org/drawingml/2006/main"/>
           <a:p xmlns:a="http://schemas.openxmlformats.org/drawingml/2006/main">
             <a:pPr algn="l">
+              <a:buNone/>
               <a:defRPr sz="975" b="1">
                 <a:solidFill>
                   <a:srgbClr val="C7F25C"/>
@@ -10268,6 +10407,7 @@
           <a:lstStyle xmlns:a="http://schemas.openxmlformats.org/drawingml/2006/main"/>
           <a:p xmlns:a="http://schemas.openxmlformats.org/drawingml/2006/main">
             <a:pPr algn="l">
+              <a:buNone/>
               <a:defRPr sz="1650" b="0">
                 <a:solidFill>
                   <a:srgbClr val="FFFFFF"/>
@@ -10318,6 +10458,7 @@
           <a:lstStyle xmlns:a="http://schemas.openxmlformats.org/drawingml/2006/main"/>
           <a:p xmlns:a="http://schemas.openxmlformats.org/drawingml/2006/main">
             <a:pPr algn="l">
+              <a:buNone/>
               <a:defRPr sz="1500" b="1">
                 <a:solidFill>
                   <a:srgbClr val="C7F25C"/>
@@ -10337,14 +10478,14 @@
       </p:sp>
       <p:pic>
         <p:nvPicPr>
-          <p:cNvPr id="24" name=""/>
+          <p:cNvPr id="26" name=""/>
           <p:cNvPicPr>
             <a:picLocks xmlns:a="http://schemas.openxmlformats.org/drawingml/2006/main" noChangeAspect="1"/>
           </p:cNvPicPr>
           <p:nvPr/>
         </p:nvPicPr>
         <p:blipFill>
-          <a:blip xmlns:r="http://schemas.openxmlformats.org/officeDocument/2006/relationships" xmlns:a="http://schemas.openxmlformats.org/drawingml/2006/main" r:embed="R66bfc8904f52442d"/>
+          <a:blip xmlns:r="http://schemas.openxmlformats.org/officeDocument/2006/relationships" xmlns:a="http://schemas.openxmlformats.org/drawingml/2006/main" r:embed="Rdbfa6739f7d24609"/>
           <a:stretch xmlns:a="http://schemas.openxmlformats.org/drawingml/2006/main"/>
         </p:blipFill>
         <p:spPr>
@@ -10419,6 +10560,7 @@
           <a:lstStyle xmlns:a="http://schemas.openxmlformats.org/drawingml/2006/main"/>
           <a:p xmlns:a="http://schemas.openxmlformats.org/drawingml/2006/main">
             <a:pPr algn="l">
+              <a:buNone/>
               <a:defRPr sz="1800" b="1">
                 <a:solidFill>
                   <a:srgbClr val="E63888"/>
@@ -10500,6 +10642,7 @@
           <a:lstStyle xmlns:a="http://schemas.openxmlformats.org/drawingml/2006/main"/>
           <a:p xmlns:a="http://schemas.openxmlformats.org/drawingml/2006/main">
             <a:pPr algn="l">
+              <a:buNone/>
               <a:defRPr sz="3150" b="1">
                 <a:solidFill>
                   <a:srgbClr val="26232A"/>
@@ -10550,6 +10693,7 @@
           <a:lstStyle xmlns:a="http://schemas.openxmlformats.org/drawingml/2006/main"/>
           <a:p xmlns:a="http://schemas.openxmlformats.org/drawingml/2006/main">
             <a:pPr algn="l">
+              <a:buNone/>
               <a:defRPr sz="750" b="1">
                 <a:solidFill>
                   <a:srgbClr val="6E6873"/>
@@ -10600,6 +10744,7 @@
           <a:lstStyle xmlns:a="http://schemas.openxmlformats.org/drawingml/2006/main"/>
           <a:p xmlns:a="http://schemas.openxmlformats.org/drawingml/2006/main">
             <a:pPr algn="r">
+              <a:buNone/>
               <a:defRPr sz="825" b="1">
                 <a:solidFill>
                   <a:srgbClr val="E63888"/>
@@ -10714,6 +10859,7 @@
           <a:lstStyle xmlns:a="http://schemas.openxmlformats.org/drawingml/2006/main"/>
           <a:p xmlns:a="http://schemas.openxmlformats.org/drawingml/2006/main">
             <a:pPr algn="ctr">
+              <a:buNone/>
               <a:defRPr sz="1350" b="1">
                 <a:solidFill>
                   <a:srgbClr val="FFFFFF"/>
@@ -10764,6 +10910,7 @@
           <a:lstStyle xmlns:a="http://schemas.openxmlformats.org/drawingml/2006/main"/>
           <a:p xmlns:a="http://schemas.openxmlformats.org/drawingml/2006/main">
             <a:pPr algn="ctr">
+              <a:buNone/>
               <a:defRPr sz="1575" b="1">
                 <a:solidFill>
                   <a:srgbClr val="3D1F5C"/>
@@ -10814,6 +10961,7 @@
           <a:lstStyle xmlns:a="http://schemas.openxmlformats.org/drawingml/2006/main"/>
           <a:p xmlns:a="http://schemas.openxmlformats.org/drawingml/2006/main">
             <a:pPr algn="ctr">
+              <a:buNone/>
               <a:defRPr sz="1275" b="0">
                 <a:solidFill>
                   <a:srgbClr val="26232A"/>
@@ -10895,6 +11043,7 @@
           <a:lstStyle xmlns:a="http://schemas.openxmlformats.org/drawingml/2006/main"/>
           <a:p xmlns:a="http://schemas.openxmlformats.org/drawingml/2006/main">
             <a:pPr algn="ctr">
+              <a:buNone/>
               <a:defRPr sz="1350" b="1">
                 <a:solidFill>
                   <a:srgbClr val="FFFFFF"/>
@@ -10945,6 +11094,7 @@
           <a:lstStyle xmlns:a="http://schemas.openxmlformats.org/drawingml/2006/main"/>
           <a:p xmlns:a="http://schemas.openxmlformats.org/drawingml/2006/main">
             <a:pPr algn="ctr">
+              <a:buNone/>
               <a:defRPr sz="1575" b="1">
                 <a:solidFill>
                   <a:srgbClr val="3D1F5C"/>
@@ -10995,6 +11145,7 @@
           <a:lstStyle xmlns:a="http://schemas.openxmlformats.org/drawingml/2006/main"/>
           <a:p xmlns:a="http://schemas.openxmlformats.org/drawingml/2006/main">
             <a:pPr algn="ctr">
+              <a:buNone/>
               <a:defRPr sz="1275" b="0">
                 <a:solidFill>
                   <a:srgbClr val="26232A"/>
@@ -11076,6 +11227,7 @@
           <a:lstStyle xmlns:a="http://schemas.openxmlformats.org/drawingml/2006/main"/>
           <a:p xmlns:a="http://schemas.openxmlformats.org/drawingml/2006/main">
             <a:pPr algn="ctr">
+              <a:buNone/>
               <a:defRPr sz="1350" b="1">
                 <a:solidFill>
                   <a:srgbClr val="FFFFFF"/>
@@ -11126,6 +11278,7 @@
           <a:lstStyle xmlns:a="http://schemas.openxmlformats.org/drawingml/2006/main"/>
           <a:p xmlns:a="http://schemas.openxmlformats.org/drawingml/2006/main">
             <a:pPr algn="ctr">
+              <a:buNone/>
               <a:defRPr sz="1575" b="1">
                 <a:solidFill>
                   <a:srgbClr val="3D1F5C"/>
@@ -11176,6 +11329,7 @@
           <a:lstStyle xmlns:a="http://schemas.openxmlformats.org/drawingml/2006/main"/>
           <a:p xmlns:a="http://schemas.openxmlformats.org/drawingml/2006/main">
             <a:pPr algn="ctr">
+              <a:buNone/>
               <a:defRPr sz="1275" b="0">
                 <a:solidFill>
                   <a:srgbClr val="26232A"/>
@@ -11257,6 +11411,7 @@
           <a:lstStyle xmlns:a="http://schemas.openxmlformats.org/drawingml/2006/main"/>
           <a:p xmlns:a="http://schemas.openxmlformats.org/drawingml/2006/main">
             <a:pPr algn="ctr">
+              <a:buNone/>
               <a:defRPr sz="1350" b="1">
                 <a:solidFill>
                   <a:srgbClr val="3D1F5C"/>
@@ -11307,6 +11462,7 @@
           <a:lstStyle xmlns:a="http://schemas.openxmlformats.org/drawingml/2006/main"/>
           <a:p xmlns:a="http://schemas.openxmlformats.org/drawingml/2006/main">
             <a:pPr algn="ctr">
+              <a:buNone/>
               <a:defRPr sz="1575" b="1">
                 <a:solidFill>
                   <a:srgbClr val="3D1F5C"/>
@@ -11357,6 +11513,7 @@
           <a:lstStyle xmlns:a="http://schemas.openxmlformats.org/drawingml/2006/main"/>
           <a:p xmlns:a="http://schemas.openxmlformats.org/drawingml/2006/main">
             <a:pPr algn="ctr">
+              <a:buNone/>
               <a:defRPr sz="1275" b="0">
                 <a:solidFill>
                   <a:srgbClr val="26232A"/>
@@ -11407,6 +11564,7 @@
           <a:lstStyle xmlns:a="http://schemas.openxmlformats.org/drawingml/2006/main"/>
           <a:p xmlns:a="http://schemas.openxmlformats.org/drawingml/2006/main">
             <a:pPr algn="ctr">
+              <a:buNone/>
               <a:defRPr sz="2100" b="1">
                 <a:solidFill>
                   <a:srgbClr val="E63888"/>
@@ -11486,6 +11644,7 @@
           <a:lstStyle xmlns:a="http://schemas.openxmlformats.org/drawingml/2006/main"/>
           <a:p xmlns:a="http://schemas.openxmlformats.org/drawingml/2006/main">
             <a:pPr algn="l">
+              <a:buNone/>
               <a:defRPr sz="1800" b="1">
                 <a:solidFill>
                   <a:srgbClr val="E63888"/>
@@ -11567,6 +11726,7 @@
           <a:lstStyle xmlns:a="http://schemas.openxmlformats.org/drawingml/2006/main"/>
           <a:p xmlns:a="http://schemas.openxmlformats.org/drawingml/2006/main">
             <a:pPr algn="l">
+              <a:buNone/>
               <a:defRPr sz="3150" b="1">
                 <a:solidFill>
                   <a:srgbClr val="FFFFFF"/>
@@ -11617,6 +11777,7 @@
           <a:lstStyle xmlns:a="http://schemas.openxmlformats.org/drawingml/2006/main"/>
           <a:p xmlns:a="http://schemas.openxmlformats.org/drawingml/2006/main">
             <a:pPr algn="l">
+              <a:buNone/>
               <a:defRPr sz="750" b="1">
                 <a:solidFill>
                   <a:srgbClr val="EAE3EC"/>
@@ -11667,6 +11828,7 @@
           <a:lstStyle xmlns:a="http://schemas.openxmlformats.org/drawingml/2006/main"/>
           <a:p xmlns:a="http://schemas.openxmlformats.org/drawingml/2006/main">
             <a:pPr algn="r">
+              <a:buNone/>
               <a:defRPr sz="825" b="1">
                 <a:solidFill>
                   <a:srgbClr val="C7F25C"/>
@@ -11717,6 +11879,7 @@
           <a:lstStyle xmlns:a="http://schemas.openxmlformats.org/drawingml/2006/main"/>
           <a:p xmlns:a="http://schemas.openxmlformats.org/drawingml/2006/main">
             <a:pPr algn="l">
+              <a:buNone/>
               <a:defRPr sz="2100" b="1">
                 <a:solidFill>
                   <a:srgbClr val="EAE3EC"/>
@@ -11734,6 +11897,7 @@
           </a:p>
           <a:p xmlns:a="http://schemas.openxmlformats.org/drawingml/2006/main">
             <a:pPr algn="l">
+              <a:buNone/>
               <a:defRPr sz="2100" b="1">
                 <a:solidFill>
                   <a:srgbClr val="EAE3EC"/>
@@ -11784,6 +11948,7 @@
           <a:lstStyle xmlns:a="http://schemas.openxmlformats.org/drawingml/2006/main"/>
           <a:p xmlns:a="http://schemas.openxmlformats.org/drawingml/2006/main">
             <a:pPr algn="ctr">
+              <a:buNone/>
               <a:defRPr sz="2850" b="1">
                 <a:solidFill>
                   <a:srgbClr val="E63888"/>
@@ -11834,6 +11999,7 @@
           <a:lstStyle xmlns:a="http://schemas.openxmlformats.org/drawingml/2006/main"/>
           <a:p xmlns:a="http://schemas.openxmlformats.org/drawingml/2006/main">
             <a:pPr algn="l">
+              <a:buNone/>
               <a:defRPr sz="2400" b="1">
                 <a:solidFill>
                   <a:srgbClr val="FFFFFF"/>
@@ -11851,6 +12017,7 @@
           </a:p>
           <a:p xmlns:a="http://schemas.openxmlformats.org/drawingml/2006/main">
             <a:pPr algn="l">
+              <a:buNone/>
               <a:defRPr sz="2400" b="1">
                 <a:solidFill>
                   <a:srgbClr val="FFFFFF"/>
@@ -11936,6 +12103,7 @@
           <a:lstStyle xmlns:a="http://schemas.openxmlformats.org/drawingml/2006/main"/>
           <a:p xmlns:a="http://schemas.openxmlformats.org/drawingml/2006/main">
             <a:pPr algn="l">
+              <a:buNone/>
               <a:defRPr sz="975" b="1">
                 <a:solidFill>
                   <a:srgbClr val="C7F25C"/>
@@ -11986,6 +12154,7 @@
           <a:lstStyle xmlns:a="http://schemas.openxmlformats.org/drawingml/2006/main"/>
           <a:p xmlns:a="http://schemas.openxmlformats.org/drawingml/2006/main">
             <a:pPr algn="l">
+              <a:buNone/>
               <a:defRPr sz="1425" b="0">
                 <a:solidFill>
                   <a:srgbClr val="FFFFFF"/>
@@ -12069,6 +12238,7 @@
           <a:lstStyle xmlns:a="http://schemas.openxmlformats.org/drawingml/2006/main"/>
           <a:p xmlns:a="http://schemas.openxmlformats.org/drawingml/2006/main">
             <a:pPr algn="l">
+              <a:buNone/>
               <a:defRPr sz="975" b="1">
                 <a:solidFill>
                   <a:srgbClr val="C7F25C"/>
@@ -12119,6 +12289,7 @@
           <a:lstStyle xmlns:a="http://schemas.openxmlformats.org/drawingml/2006/main"/>
           <a:p xmlns:a="http://schemas.openxmlformats.org/drawingml/2006/main">
             <a:pPr algn="l">
+              <a:buNone/>
               <a:defRPr sz="1650" b="1">
                 <a:solidFill>
                   <a:srgbClr val="FFFFFF"/>
@@ -12202,6 +12373,7 @@
           <a:lstStyle xmlns:a="http://schemas.openxmlformats.org/drawingml/2006/main"/>
           <a:p xmlns:a="http://schemas.openxmlformats.org/drawingml/2006/main">
             <a:pPr algn="l">
+              <a:buNone/>
               <a:defRPr sz="975" b="1">
                 <a:solidFill>
                   <a:srgbClr val="3D1F5C"/>
@@ -12252,6 +12424,7 @@
           <a:lstStyle xmlns:a="http://schemas.openxmlformats.org/drawingml/2006/main"/>
           <a:p xmlns:a="http://schemas.openxmlformats.org/drawingml/2006/main">
             <a:pPr algn="l">
+              <a:buNone/>
               <a:defRPr sz="1350" b="1">
                 <a:solidFill>
                   <a:srgbClr val="3D1F5C"/>
@@ -12331,6 +12504,7 @@
           <a:lstStyle xmlns:a="http://schemas.openxmlformats.org/drawingml/2006/main"/>
           <a:p xmlns:a="http://schemas.openxmlformats.org/drawingml/2006/main">
             <a:pPr algn="l">
+              <a:buNone/>
               <a:defRPr sz="1800" b="1">
                 <a:solidFill>
                   <a:srgbClr val="E63888"/>
@@ -12412,6 +12586,7 @@
           <a:lstStyle xmlns:a="http://schemas.openxmlformats.org/drawingml/2006/main"/>
           <a:p xmlns:a="http://schemas.openxmlformats.org/drawingml/2006/main">
             <a:pPr algn="l">
+              <a:buNone/>
               <a:defRPr sz="3150" b="1">
                 <a:solidFill>
                   <a:srgbClr val="26232A"/>
@@ -12462,6 +12637,7 @@
           <a:lstStyle xmlns:a="http://schemas.openxmlformats.org/drawingml/2006/main"/>
           <a:p xmlns:a="http://schemas.openxmlformats.org/drawingml/2006/main">
             <a:pPr algn="l">
+              <a:buNone/>
               <a:defRPr sz="750" b="1">
                 <a:solidFill>
                   <a:srgbClr val="6E6873"/>
@@ -12512,6 +12688,7 @@
           <a:lstStyle xmlns:a="http://schemas.openxmlformats.org/drawingml/2006/main"/>
           <a:p xmlns:a="http://schemas.openxmlformats.org/drawingml/2006/main">
             <a:pPr algn="r">
+              <a:buNone/>
               <a:defRPr sz="825" b="1">
                 <a:solidFill>
                   <a:srgbClr val="E63888"/>
@@ -12597,6 +12774,7 @@
           <a:lstStyle xmlns:a="http://schemas.openxmlformats.org/drawingml/2006/main"/>
           <a:p xmlns:a="http://schemas.openxmlformats.org/drawingml/2006/main">
             <a:pPr algn="l">
+              <a:buNone/>
               <a:defRPr sz="1500" b="1">
                 <a:solidFill>
                   <a:srgbClr val="E63888"/>
@@ -12647,6 +12825,7 @@
           <a:lstStyle xmlns:a="http://schemas.openxmlformats.org/drawingml/2006/main"/>
           <a:p xmlns:a="http://schemas.openxmlformats.org/drawingml/2006/main">
             <a:pPr algn="l">
+              <a:buNone/>
               <a:defRPr sz="1200" b="1">
                 <a:solidFill>
                   <a:srgbClr val="26232A"/>
@@ -12732,6 +12911,7 @@
           <a:lstStyle xmlns:a="http://schemas.openxmlformats.org/drawingml/2006/main"/>
           <a:p xmlns:a="http://schemas.openxmlformats.org/drawingml/2006/main">
             <a:pPr algn="l">
+              <a:buNone/>
               <a:defRPr sz="1500" b="1">
                 <a:solidFill>
                   <a:srgbClr val="E63888"/>
@@ -12782,6 +12962,7 @@
           <a:lstStyle xmlns:a="http://schemas.openxmlformats.org/drawingml/2006/main"/>
           <a:p xmlns:a="http://schemas.openxmlformats.org/drawingml/2006/main">
             <a:pPr algn="l">
+              <a:buNone/>
               <a:defRPr sz="1200" b="1">
                 <a:solidFill>
                   <a:srgbClr val="26232A"/>
@@ -12867,6 +13048,7 @@
           <a:lstStyle xmlns:a="http://schemas.openxmlformats.org/drawingml/2006/main"/>
           <a:p xmlns:a="http://schemas.openxmlformats.org/drawingml/2006/main">
             <a:pPr algn="l">
+              <a:buNone/>
               <a:defRPr sz="1500" b="1">
                 <a:solidFill>
                   <a:srgbClr val="E63888"/>
@@ -12917,6 +13099,7 @@
           <a:lstStyle xmlns:a="http://schemas.openxmlformats.org/drawingml/2006/main"/>
           <a:p xmlns:a="http://schemas.openxmlformats.org/drawingml/2006/main">
             <a:pPr algn="l">
+              <a:buNone/>
               <a:defRPr sz="1200" b="1">
                 <a:solidFill>
                   <a:srgbClr val="26232A"/>
@@ -13002,6 +13185,7 @@
           <a:lstStyle xmlns:a="http://schemas.openxmlformats.org/drawingml/2006/main"/>
           <a:p xmlns:a="http://schemas.openxmlformats.org/drawingml/2006/main">
             <a:pPr algn="l">
+              <a:buNone/>
               <a:defRPr sz="1500" b="1">
                 <a:solidFill>
                   <a:srgbClr val="E63888"/>
@@ -13052,6 +13236,7 @@
           <a:lstStyle xmlns:a="http://schemas.openxmlformats.org/drawingml/2006/main"/>
           <a:p xmlns:a="http://schemas.openxmlformats.org/drawingml/2006/main">
             <a:pPr algn="l">
+              <a:buNone/>
               <a:defRPr sz="1200" b="1">
                 <a:solidFill>
                   <a:srgbClr val="26232A"/>
@@ -13137,6 +13322,7 @@
           <a:lstStyle xmlns:a="http://schemas.openxmlformats.org/drawingml/2006/main"/>
           <a:p xmlns:a="http://schemas.openxmlformats.org/drawingml/2006/main">
             <a:pPr algn="l">
+              <a:buNone/>
               <a:defRPr sz="1500" b="1">
                 <a:solidFill>
                   <a:srgbClr val="C7F25C"/>
@@ -13187,6 +13373,7 @@
           <a:lstStyle xmlns:a="http://schemas.openxmlformats.org/drawingml/2006/main"/>
           <a:p xmlns:a="http://schemas.openxmlformats.org/drawingml/2006/main">
             <a:pPr algn="l">
+              <a:buNone/>
               <a:defRPr sz="1200" b="1">
                 <a:solidFill>
                   <a:srgbClr val="FFFFFF"/>
@@ -13272,6 +13459,7 @@
           <a:lstStyle xmlns:a="http://schemas.openxmlformats.org/drawingml/2006/main"/>
           <a:p xmlns:a="http://schemas.openxmlformats.org/drawingml/2006/main">
             <a:pPr algn="l">
+              <a:buNone/>
               <a:defRPr sz="1500" b="1">
                 <a:solidFill>
                   <a:srgbClr val="C7F25C"/>
@@ -13322,6 +13510,7 @@
           <a:lstStyle xmlns:a="http://schemas.openxmlformats.org/drawingml/2006/main"/>
           <a:p xmlns:a="http://schemas.openxmlformats.org/drawingml/2006/main">
             <a:pPr algn="l">
+              <a:buNone/>
               <a:defRPr sz="1200" b="1">
                 <a:solidFill>
                   <a:srgbClr val="FFFFFF"/>
@@ -13372,6 +13561,7 @@
           <a:lstStyle xmlns:a="http://schemas.openxmlformats.org/drawingml/2006/main"/>
           <a:p xmlns:a="http://schemas.openxmlformats.org/drawingml/2006/main">
             <a:pPr algn="ctr">
+              <a:buNone/>
               <a:defRPr sz="1650" b="1">
                 <a:solidFill>
                   <a:srgbClr val="3D1F5C"/>
@@ -13451,6 +13641,7 @@
           <a:lstStyle xmlns:a="http://schemas.openxmlformats.org/drawingml/2006/main"/>
           <a:p xmlns:a="http://schemas.openxmlformats.org/drawingml/2006/main">
             <a:pPr algn="l">
+              <a:buNone/>
               <a:defRPr sz="1800" b="1">
                 <a:solidFill>
                   <a:srgbClr val="E63888"/>
@@ -13532,6 +13723,7 @@
           <a:lstStyle xmlns:a="http://schemas.openxmlformats.org/drawingml/2006/main"/>
           <a:p xmlns:a="http://schemas.openxmlformats.org/drawingml/2006/main">
             <a:pPr algn="l">
+              <a:buNone/>
               <a:defRPr sz="3150" b="1">
                 <a:solidFill>
                   <a:srgbClr val="FFFFFF"/>
@@ -13582,6 +13774,7 @@
           <a:lstStyle xmlns:a="http://schemas.openxmlformats.org/drawingml/2006/main"/>
           <a:p xmlns:a="http://schemas.openxmlformats.org/drawingml/2006/main">
             <a:pPr algn="l">
+              <a:buNone/>
               <a:defRPr sz="750" b="1">
                 <a:solidFill>
                   <a:srgbClr val="EAE3EC"/>
@@ -13632,6 +13825,7 @@
           <a:lstStyle xmlns:a="http://schemas.openxmlformats.org/drawingml/2006/main"/>
           <a:p xmlns:a="http://schemas.openxmlformats.org/drawingml/2006/main">
             <a:pPr algn="r">
+              <a:buNone/>
               <a:defRPr sz="825" b="1">
                 <a:solidFill>
                   <a:srgbClr val="C7F25C"/>
@@ -13682,6 +13876,7 @@
           <a:lstStyle xmlns:a="http://schemas.openxmlformats.org/drawingml/2006/main"/>
           <a:p xmlns:a="http://schemas.openxmlformats.org/drawingml/2006/main">
             <a:pPr algn="l">
+              <a:buNone/>
               <a:defRPr sz="2850" b="1">
                 <a:solidFill>
                   <a:srgbClr val="E63888"/>
@@ -13732,6 +13927,7 @@
           <a:lstStyle xmlns:a="http://schemas.openxmlformats.org/drawingml/2006/main"/>
           <a:p xmlns:a="http://schemas.openxmlformats.org/drawingml/2006/main">
             <a:pPr algn="l">
+              <a:buNone/>
               <a:defRPr sz="2850" b="1">
                 <a:solidFill>
                   <a:srgbClr val="FFFFFF"/>
@@ -13782,6 +13978,7 @@
           <a:lstStyle xmlns:a="http://schemas.openxmlformats.org/drawingml/2006/main"/>
           <a:p xmlns:a="http://schemas.openxmlformats.org/drawingml/2006/main">
             <a:pPr algn="l">
+              <a:buNone/>
               <a:defRPr sz="2850" b="1">
                 <a:solidFill>
                   <a:srgbClr val="C7F25C"/>
@@ -13832,6 +14029,7 @@
           <a:lstStyle xmlns:a="http://schemas.openxmlformats.org/drawingml/2006/main"/>
           <a:p xmlns:a="http://schemas.openxmlformats.org/drawingml/2006/main">
             <a:pPr algn="l">
+              <a:buNone/>
               <a:defRPr sz="2850" b="1">
                 <a:solidFill>
                   <a:srgbClr val="FFFFFF"/>
@@ -13882,6 +14080,7 @@
           <a:lstStyle xmlns:a="http://schemas.openxmlformats.org/drawingml/2006/main"/>
           <a:p xmlns:a="http://schemas.openxmlformats.org/drawingml/2006/main">
             <a:pPr algn="l">
+              <a:buNone/>
               <a:defRPr sz="2850" b="1">
                 <a:solidFill>
                   <a:srgbClr val="E63888"/>
@@ -13963,6 +14162,7 @@
           <a:lstStyle xmlns:a="http://schemas.openxmlformats.org/drawingml/2006/main"/>
           <a:p xmlns:a="http://schemas.openxmlformats.org/drawingml/2006/main">
             <a:pPr algn="ctr">
+              <a:buNone/>
               <a:defRPr sz="1350" b="0">
                 <a:solidFill>
                   <a:srgbClr val="EAE3EC"/>
@@ -14042,6 +14242,7 @@
           <a:lstStyle xmlns:a="http://schemas.openxmlformats.org/drawingml/2006/main"/>
           <a:p xmlns:a="http://schemas.openxmlformats.org/drawingml/2006/main">
             <a:pPr algn="l">
+              <a:buNone/>
               <a:defRPr sz="1800" b="1">
                 <a:solidFill>
                   <a:srgbClr val="E63888"/>
@@ -14123,6 +14324,7 @@
           <a:lstStyle xmlns:a="http://schemas.openxmlformats.org/drawingml/2006/main"/>
           <a:p xmlns:a="http://schemas.openxmlformats.org/drawingml/2006/main">
             <a:pPr algn="l">
+              <a:buNone/>
               <a:defRPr sz="3150" b="1">
                 <a:solidFill>
                   <a:srgbClr val="26232A"/>
@@ -14173,6 +14375,7 @@
           <a:lstStyle xmlns:a="http://schemas.openxmlformats.org/drawingml/2006/main"/>
           <a:p xmlns:a="http://schemas.openxmlformats.org/drawingml/2006/main">
             <a:pPr algn="l">
+              <a:buNone/>
               <a:defRPr sz="750" b="1">
                 <a:solidFill>
                   <a:srgbClr val="6E6873"/>
@@ -14223,6 +14426,7 @@
           <a:lstStyle xmlns:a="http://schemas.openxmlformats.org/drawingml/2006/main"/>
           <a:p xmlns:a="http://schemas.openxmlformats.org/drawingml/2006/main">
             <a:pPr algn="r">
+              <a:buNone/>
               <a:defRPr sz="825" b="1">
                 <a:solidFill>
                   <a:srgbClr val="E63888"/>
@@ -14308,6 +14512,7 @@
           <a:lstStyle xmlns:a="http://schemas.openxmlformats.org/drawingml/2006/main"/>
           <a:p xmlns:a="http://schemas.openxmlformats.org/drawingml/2006/main">
             <a:pPr algn="l">
+              <a:buNone/>
               <a:defRPr sz="1050" b="1">
                 <a:solidFill>
                   <a:srgbClr val="E63888"/>
@@ -14358,6 +14563,7 @@
           <a:lstStyle xmlns:a="http://schemas.openxmlformats.org/drawingml/2006/main"/>
           <a:p xmlns:a="http://schemas.openxmlformats.org/drawingml/2006/main">
             <a:pPr algn="l">
+              <a:buNone/>
               <a:defRPr sz="1500" b="1">
                 <a:solidFill>
                   <a:srgbClr val="26232A"/>
@@ -14408,6 +14614,7 @@
           <a:lstStyle xmlns:a="http://schemas.openxmlformats.org/drawingml/2006/main"/>
           <a:p xmlns:a="http://schemas.openxmlformats.org/drawingml/2006/main">
             <a:pPr algn="l">
+              <a:buNone/>
               <a:defRPr sz="1125" b="0">
                 <a:solidFill>
                   <a:srgbClr val="6E6873"/>
@@ -14458,6 +14665,7 @@
           <a:lstStyle xmlns:a="http://schemas.openxmlformats.org/drawingml/2006/main"/>
           <a:p xmlns:a="http://schemas.openxmlformats.org/drawingml/2006/main">
             <a:pPr algn="ctr">
+              <a:buNone/>
               <a:defRPr sz="2100" b="1">
                 <a:solidFill>
                   <a:srgbClr val="E63888"/>
@@ -14543,6 +14751,7 @@
           <a:lstStyle xmlns:a="http://schemas.openxmlformats.org/drawingml/2006/main"/>
           <a:p xmlns:a="http://schemas.openxmlformats.org/drawingml/2006/main">
             <a:pPr algn="l">
+              <a:buNone/>
               <a:defRPr sz="1050" b="1">
                 <a:solidFill>
                   <a:srgbClr val="E63888"/>
@@ -14593,6 +14802,7 @@
           <a:lstStyle xmlns:a="http://schemas.openxmlformats.org/drawingml/2006/main"/>
           <a:p xmlns:a="http://schemas.openxmlformats.org/drawingml/2006/main">
             <a:pPr algn="l">
+              <a:buNone/>
               <a:defRPr sz="1500" b="1">
                 <a:solidFill>
                   <a:srgbClr val="26232A"/>
@@ -14643,6 +14853,7 @@
           <a:lstStyle xmlns:a="http://schemas.openxmlformats.org/drawingml/2006/main"/>
           <a:p xmlns:a="http://schemas.openxmlformats.org/drawingml/2006/main">
             <a:pPr algn="l">
+              <a:buNone/>
               <a:defRPr sz="1125" b="0">
                 <a:solidFill>
                   <a:srgbClr val="6E6873"/>
@@ -14693,6 +14904,7 @@
           <a:lstStyle xmlns:a="http://schemas.openxmlformats.org/drawingml/2006/main"/>
           <a:p xmlns:a="http://schemas.openxmlformats.org/drawingml/2006/main">
             <a:pPr algn="ctr">
+              <a:buNone/>
               <a:defRPr sz="2100" b="1">
                 <a:solidFill>
                   <a:srgbClr val="E63888"/>
@@ -14778,6 +14990,7 @@
           <a:lstStyle xmlns:a="http://schemas.openxmlformats.org/drawingml/2006/main"/>
           <a:p xmlns:a="http://schemas.openxmlformats.org/drawingml/2006/main">
             <a:pPr algn="l">
+              <a:buNone/>
               <a:defRPr sz="1050" b="1">
                 <a:solidFill>
                   <a:srgbClr val="E63888"/>
@@ -14828,6 +15041,7 @@
           <a:lstStyle xmlns:a="http://schemas.openxmlformats.org/drawingml/2006/main"/>
           <a:p xmlns:a="http://schemas.openxmlformats.org/drawingml/2006/main">
             <a:pPr algn="l">
+              <a:buNone/>
               <a:defRPr sz="1500" b="1">
                 <a:solidFill>
                   <a:srgbClr val="26232A"/>
@@ -14878,6 +15092,7 @@
           <a:lstStyle xmlns:a="http://schemas.openxmlformats.org/drawingml/2006/main"/>
           <a:p xmlns:a="http://schemas.openxmlformats.org/drawingml/2006/main">
             <a:pPr algn="l">
+              <a:buNone/>
               <a:defRPr sz="1125" b="0">
                 <a:solidFill>
                   <a:srgbClr val="6E6873"/>
@@ -14928,6 +15143,7 @@
           <a:lstStyle xmlns:a="http://schemas.openxmlformats.org/drawingml/2006/main"/>
           <a:p xmlns:a="http://schemas.openxmlformats.org/drawingml/2006/main">
             <a:pPr algn="ctr">
+              <a:buNone/>
               <a:defRPr sz="2100" b="1">
                 <a:solidFill>
                   <a:srgbClr val="E63888"/>
@@ -15013,6 +15229,7 @@
           <a:lstStyle xmlns:a="http://schemas.openxmlformats.org/drawingml/2006/main"/>
           <a:p xmlns:a="http://schemas.openxmlformats.org/drawingml/2006/main">
             <a:pPr algn="l">
+              <a:buNone/>
               <a:defRPr sz="1050" b="1">
                 <a:solidFill>
                   <a:srgbClr val="C7F25C"/>
@@ -15063,6 +15280,7 @@
           <a:lstStyle xmlns:a="http://schemas.openxmlformats.org/drawingml/2006/main"/>
           <a:p xmlns:a="http://schemas.openxmlformats.org/drawingml/2006/main">
             <a:pPr algn="l">
+              <a:buNone/>
               <a:defRPr sz="1500" b="1">
                 <a:solidFill>
                   <a:srgbClr val="FFFFFF"/>
@@ -15113,6 +15331,7 @@
           <a:lstStyle xmlns:a="http://schemas.openxmlformats.org/drawingml/2006/main"/>
           <a:p xmlns:a="http://schemas.openxmlformats.org/drawingml/2006/main">
             <a:pPr algn="l">
+              <a:buNone/>
               <a:defRPr sz="1125" b="0">
                 <a:solidFill>
                   <a:srgbClr val="EAE3EC"/>
@@ -15163,6 +15382,7 @@
           <a:lstStyle xmlns:a="http://schemas.openxmlformats.org/drawingml/2006/main"/>
           <a:p xmlns:a="http://schemas.openxmlformats.org/drawingml/2006/main">
             <a:pPr algn="ctr">
+              <a:buNone/>
               <a:defRPr sz="2100" b="1">
                 <a:solidFill>
                   <a:srgbClr val="3D1F5C"/>
@@ -15242,6 +15462,7 @@
           <a:lstStyle xmlns:a="http://schemas.openxmlformats.org/drawingml/2006/main"/>
           <a:p xmlns:a="http://schemas.openxmlformats.org/drawingml/2006/main">
             <a:pPr algn="l">
+              <a:buNone/>
               <a:defRPr sz="1800" b="1">
                 <a:solidFill>
                   <a:srgbClr val="E63888"/>
@@ -15323,6 +15544,7 @@
           <a:lstStyle xmlns:a="http://schemas.openxmlformats.org/drawingml/2006/main"/>
           <a:p xmlns:a="http://schemas.openxmlformats.org/drawingml/2006/main">
             <a:pPr algn="l">
+              <a:buNone/>
               <a:defRPr sz="3150" b="1">
                 <a:solidFill>
                   <a:srgbClr val="26232A"/>
@@ -15373,6 +15595,7 @@
           <a:lstStyle xmlns:a="http://schemas.openxmlformats.org/drawingml/2006/main"/>
           <a:p xmlns:a="http://schemas.openxmlformats.org/drawingml/2006/main">
             <a:pPr algn="l">
+              <a:buNone/>
               <a:defRPr sz="750" b="1">
                 <a:solidFill>
                   <a:srgbClr val="6E6873"/>
@@ -15423,6 +15646,7 @@
           <a:lstStyle xmlns:a="http://schemas.openxmlformats.org/drawingml/2006/main"/>
           <a:p xmlns:a="http://schemas.openxmlformats.org/drawingml/2006/main">
             <a:pPr algn="r">
+              <a:buNone/>
               <a:defRPr sz="825" b="1">
                 <a:solidFill>
                   <a:srgbClr val="E63888"/>
@@ -15473,6 +15697,7 @@
           <a:lstStyle xmlns:a="http://schemas.openxmlformats.org/drawingml/2006/main"/>
           <a:p xmlns:a="http://schemas.openxmlformats.org/drawingml/2006/main">
             <a:pPr algn="ctr">
+              <a:buNone/>
               <a:defRPr sz="6450" b="1">
                 <a:solidFill>
                   <a:srgbClr val="3D1F5C"/>
@@ -15523,6 +15748,7 @@
           <a:lstStyle xmlns:a="http://schemas.openxmlformats.org/drawingml/2006/main"/>
           <a:p xmlns:a="http://schemas.openxmlformats.org/drawingml/2006/main">
             <a:pPr algn="ctr">
+              <a:buNone/>
               <a:defRPr sz="3450" b="1">
                 <a:solidFill>
                   <a:srgbClr val="E63888"/>
@@ -15573,6 +15799,7 @@
           <a:lstStyle xmlns:a="http://schemas.openxmlformats.org/drawingml/2006/main"/>
           <a:p xmlns:a="http://schemas.openxmlformats.org/drawingml/2006/main">
             <a:pPr algn="ctr">
+              <a:buNone/>
               <a:defRPr sz="6450" b="1">
                 <a:solidFill>
                   <a:srgbClr val="3D1F5C"/>
@@ -15623,6 +15850,7 @@
           <a:lstStyle xmlns:a="http://schemas.openxmlformats.org/drawingml/2006/main"/>
           <a:p xmlns:a="http://schemas.openxmlformats.org/drawingml/2006/main">
             <a:pPr algn="ctr">
+              <a:buNone/>
               <a:defRPr sz="3450" b="1">
                 <a:solidFill>
                   <a:srgbClr val="E63888"/>
@@ -15673,6 +15901,7 @@
           <a:lstStyle xmlns:a="http://schemas.openxmlformats.org/drawingml/2006/main"/>
           <a:p xmlns:a="http://schemas.openxmlformats.org/drawingml/2006/main">
             <a:pPr algn="ctr">
+              <a:buNone/>
               <a:defRPr sz="6450" b="1">
                 <a:solidFill>
                   <a:srgbClr val="3D1F5C"/>
@@ -15723,6 +15952,7 @@
           <a:lstStyle xmlns:a="http://schemas.openxmlformats.org/drawingml/2006/main"/>
           <a:p xmlns:a="http://schemas.openxmlformats.org/drawingml/2006/main">
             <a:pPr algn="ctr">
+              <a:buNone/>
               <a:defRPr sz="1200" b="1">
                 <a:solidFill>
                   <a:srgbClr val="6E6873"/>
@@ -15773,6 +16003,7 @@
           <a:lstStyle xmlns:a="http://schemas.openxmlformats.org/drawingml/2006/main"/>
           <a:p xmlns:a="http://schemas.openxmlformats.org/drawingml/2006/main">
             <a:pPr algn="ctr">
+              <a:buNone/>
               <a:defRPr sz="1200" b="1">
                 <a:solidFill>
                   <a:srgbClr val="6E6873"/>
@@ -15823,6 +16054,7 @@
           <a:lstStyle xmlns:a="http://schemas.openxmlformats.org/drawingml/2006/main"/>
           <a:p xmlns:a="http://schemas.openxmlformats.org/drawingml/2006/main">
             <a:pPr algn="ctr">
+              <a:buNone/>
               <a:defRPr sz="1200" b="1">
                 <a:solidFill>
                   <a:srgbClr val="6E6873"/>
@@ -15906,6 +16138,7 @@
           <a:lstStyle xmlns:a="http://schemas.openxmlformats.org/drawingml/2006/main"/>
           <a:p xmlns:a="http://schemas.openxmlformats.org/drawingml/2006/main">
             <a:pPr algn="l">
+              <a:buNone/>
               <a:defRPr sz="975" b="1">
                 <a:solidFill>
                   <a:srgbClr val="C7F25C"/>
@@ -15956,6 +16189,7 @@
           <a:lstStyle xmlns:a="http://schemas.openxmlformats.org/drawingml/2006/main"/>
           <a:p xmlns:a="http://schemas.openxmlformats.org/drawingml/2006/main">
             <a:pPr algn="l">
+              <a:buNone/>
               <a:defRPr sz="1575" b="1">
                 <a:solidFill>
                   <a:srgbClr val="FFFFFF"/>
@@ -15973,6 +16207,7 @@
           </a:p>
           <a:p xmlns:a="http://schemas.openxmlformats.org/drawingml/2006/main">
             <a:pPr algn="l">
+              <a:buNone/>
               <a:defRPr sz="1575" b="1">
                 <a:solidFill>
                   <a:srgbClr val="FFFFFF"/>
@@ -15990,6 +16225,7 @@
           </a:p>
           <a:p xmlns:a="http://schemas.openxmlformats.org/drawingml/2006/main">
             <a:pPr algn="l">
+              <a:buNone/>
               <a:defRPr sz="1575" b="1">
                 <a:solidFill>
                   <a:srgbClr val="FFFFFF"/>
@@ -16007,6 +16243,7 @@
           </a:p>
           <a:p xmlns:a="http://schemas.openxmlformats.org/drawingml/2006/main">
             <a:pPr algn="l">
+              <a:buNone/>
               <a:defRPr sz="1575" b="1">
                 <a:solidFill>
                   <a:srgbClr val="FFFFFF"/>
@@ -16057,6 +16294,7 @@
           <a:lstStyle xmlns:a="http://schemas.openxmlformats.org/drawingml/2006/main"/>
           <a:p xmlns:a="http://schemas.openxmlformats.org/drawingml/2006/main">
             <a:pPr algn="ctr">
+              <a:buNone/>
               <a:defRPr sz="1650" b="1">
                 <a:solidFill>
                   <a:srgbClr val="E63888"/>
@@ -16136,6 +16374,7 @@
           <a:lstStyle xmlns:a="http://schemas.openxmlformats.org/drawingml/2006/main"/>
           <a:p xmlns:a="http://schemas.openxmlformats.org/drawingml/2006/main">
             <a:pPr algn="l">
+              <a:buNone/>
               <a:defRPr sz="1800" b="1">
                 <a:solidFill>
                   <a:srgbClr val="E63888"/>
@@ -16217,6 +16456,7 @@
           <a:lstStyle xmlns:a="http://schemas.openxmlformats.org/drawingml/2006/main"/>
           <a:p xmlns:a="http://schemas.openxmlformats.org/drawingml/2006/main">
             <a:pPr algn="l">
+              <a:buNone/>
               <a:defRPr sz="3150" b="1">
                 <a:solidFill>
                   <a:srgbClr val="FFFFFF"/>
@@ -16267,6 +16507,7 @@
           <a:lstStyle xmlns:a="http://schemas.openxmlformats.org/drawingml/2006/main"/>
           <a:p xmlns:a="http://schemas.openxmlformats.org/drawingml/2006/main">
             <a:pPr algn="l">
+              <a:buNone/>
               <a:defRPr sz="750" b="1">
                 <a:solidFill>
                   <a:srgbClr val="EAE3EC"/>
@@ -16317,6 +16558,7 @@
           <a:lstStyle xmlns:a="http://schemas.openxmlformats.org/drawingml/2006/main"/>
           <a:p xmlns:a="http://schemas.openxmlformats.org/drawingml/2006/main">
             <a:pPr algn="r">
+              <a:buNone/>
               <a:defRPr sz="825" b="1">
                 <a:solidFill>
                   <a:srgbClr val="C7F25C"/>
@@ -16398,6 +16640,7 @@
           <a:lstStyle xmlns:a="http://schemas.openxmlformats.org/drawingml/2006/main"/>
           <a:p xmlns:a="http://schemas.openxmlformats.org/drawingml/2006/main">
             <a:pPr algn="ctr">
+              <a:buNone/>
               <a:defRPr sz="1200" b="1">
                 <a:solidFill>
                   <a:srgbClr val="FFFFFF"/>
@@ -16448,6 +16691,7 @@
           <a:lstStyle xmlns:a="http://schemas.openxmlformats.org/drawingml/2006/main"/>
           <a:p xmlns:a="http://schemas.openxmlformats.org/drawingml/2006/main">
             <a:pPr algn="l">
+              <a:buNone/>
               <a:defRPr sz="1575" b="0">
                 <a:solidFill>
                   <a:srgbClr val="FFFFFF"/>
@@ -16529,6 +16773,7 @@
           <a:lstStyle xmlns:a="http://schemas.openxmlformats.org/drawingml/2006/main"/>
           <a:p xmlns:a="http://schemas.openxmlformats.org/drawingml/2006/main">
             <a:pPr algn="ctr">
+              <a:buNone/>
               <a:defRPr sz="1200" b="1">
                 <a:solidFill>
                   <a:srgbClr val="FFFFFF"/>
@@ -16579,6 +16824,7 @@
           <a:lstStyle xmlns:a="http://schemas.openxmlformats.org/drawingml/2006/main"/>
           <a:p xmlns:a="http://schemas.openxmlformats.org/drawingml/2006/main">
             <a:pPr algn="l">
+              <a:buNone/>
               <a:defRPr sz="1575" b="0">
                 <a:solidFill>
                   <a:srgbClr val="FFFFFF"/>
@@ -16660,6 +16906,7 @@
           <a:lstStyle xmlns:a="http://schemas.openxmlformats.org/drawingml/2006/main"/>
           <a:p xmlns:a="http://schemas.openxmlformats.org/drawingml/2006/main">
             <a:pPr algn="ctr">
+              <a:buNone/>
               <a:defRPr sz="1200" b="1">
                 <a:solidFill>
                   <a:srgbClr val="FFFFFF"/>
@@ -16710,6 +16957,7 @@
           <a:lstStyle xmlns:a="http://schemas.openxmlformats.org/drawingml/2006/main"/>
           <a:p xmlns:a="http://schemas.openxmlformats.org/drawingml/2006/main">
             <a:pPr algn="l">
+              <a:buNone/>
               <a:defRPr sz="1575" b="0">
                 <a:solidFill>
                   <a:srgbClr val="FFFFFF"/>
@@ -16791,6 +17039,7 @@
           <a:lstStyle xmlns:a="http://schemas.openxmlformats.org/drawingml/2006/main"/>
           <a:p xmlns:a="http://schemas.openxmlformats.org/drawingml/2006/main">
             <a:pPr algn="ctr">
+              <a:buNone/>
               <a:defRPr sz="1200" b="1">
                 <a:solidFill>
                   <a:srgbClr val="FFFFFF"/>
@@ -16841,6 +17090,7 @@
           <a:lstStyle xmlns:a="http://schemas.openxmlformats.org/drawingml/2006/main"/>
           <a:p xmlns:a="http://schemas.openxmlformats.org/drawingml/2006/main">
             <a:pPr algn="l">
+              <a:buNone/>
               <a:defRPr sz="1575" b="0">
                 <a:solidFill>
                   <a:srgbClr val="FFFFFF"/>
@@ -16922,6 +17172,7 @@
           <a:lstStyle xmlns:a="http://schemas.openxmlformats.org/drawingml/2006/main"/>
           <a:p xmlns:a="http://schemas.openxmlformats.org/drawingml/2006/main">
             <a:pPr algn="ctr">
+              <a:buNone/>
               <a:defRPr sz="1200" b="1">
                 <a:solidFill>
                   <a:srgbClr val="3D1F5C"/>
@@ -16972,6 +17223,7 @@
           <a:lstStyle xmlns:a="http://schemas.openxmlformats.org/drawingml/2006/main"/>
           <a:p xmlns:a="http://schemas.openxmlformats.org/drawingml/2006/main">
             <a:pPr algn="l">
+              <a:buNone/>
               <a:defRPr sz="1575" b="1">
                 <a:solidFill>
                   <a:srgbClr val="FFFFFF"/>
@@ -17084,6 +17336,7 @@
           <a:lstStyle xmlns:a="http://schemas.openxmlformats.org/drawingml/2006/main"/>
           <a:p xmlns:a="http://schemas.openxmlformats.org/drawingml/2006/main">
             <a:pPr algn="ctr">
+              <a:buNone/>
               <a:defRPr sz="4800" b="1">
                 <a:solidFill>
                   <a:srgbClr val="C7F25C"/>
@@ -17134,6 +17387,7 @@
           <a:lstStyle xmlns:a="http://schemas.openxmlformats.org/drawingml/2006/main"/>
           <a:p xmlns:a="http://schemas.openxmlformats.org/drawingml/2006/main">
             <a:pPr algn="ctr">
+              <a:buNone/>
               <a:defRPr sz="1500" b="1">
                 <a:solidFill>
                   <a:srgbClr val="FFFFFF"/>
@@ -17184,6 +17438,7 @@
           <a:lstStyle xmlns:a="http://schemas.openxmlformats.org/drawingml/2006/main"/>
           <a:p xmlns:a="http://schemas.openxmlformats.org/drawingml/2006/main">
             <a:pPr algn="ctr">
+              <a:buNone/>
               <a:defRPr sz="1725" b="1">
                 <a:solidFill>
                   <a:srgbClr val="C7F25C"/>
@@ -17263,6 +17518,7 @@
           <a:lstStyle xmlns:a="http://schemas.openxmlformats.org/drawingml/2006/main"/>
           <a:p xmlns:a="http://schemas.openxmlformats.org/drawingml/2006/main">
             <a:pPr algn="l">
+              <a:buNone/>
               <a:defRPr sz="1800" b="1">
                 <a:solidFill>
                   <a:srgbClr val="E63888"/>
@@ -17344,6 +17600,7 @@
           <a:lstStyle xmlns:a="http://schemas.openxmlformats.org/drawingml/2006/main"/>
           <a:p xmlns:a="http://schemas.openxmlformats.org/drawingml/2006/main">
             <a:pPr algn="l">
+              <a:buNone/>
               <a:defRPr sz="3150" b="1">
                 <a:solidFill>
                   <a:srgbClr val="26232A"/>
@@ -17394,6 +17651,7 @@
           <a:lstStyle xmlns:a="http://schemas.openxmlformats.org/drawingml/2006/main"/>
           <a:p xmlns:a="http://schemas.openxmlformats.org/drawingml/2006/main">
             <a:pPr algn="l">
+              <a:buNone/>
               <a:defRPr sz="750" b="1">
                 <a:solidFill>
                   <a:srgbClr val="6E6873"/>
@@ -17444,6 +17702,7 @@
           <a:lstStyle xmlns:a="http://schemas.openxmlformats.org/drawingml/2006/main"/>
           <a:p xmlns:a="http://schemas.openxmlformats.org/drawingml/2006/main">
             <a:pPr algn="r">
+              <a:buNone/>
               <a:defRPr sz="825" b="1">
                 <a:solidFill>
                   <a:srgbClr val="E63888"/>
@@ -17527,6 +17786,7 @@
           <a:lstStyle xmlns:a="http://schemas.openxmlformats.org/drawingml/2006/main"/>
           <a:p xmlns:a="http://schemas.openxmlformats.org/drawingml/2006/main">
             <a:pPr algn="l">
+              <a:buNone/>
               <a:defRPr sz="1275" b="1">
                 <a:solidFill>
                   <a:srgbClr val="E63888"/>
@@ -17577,6 +17837,7 @@
           <a:lstStyle xmlns:a="http://schemas.openxmlformats.org/drawingml/2006/main"/>
           <a:p xmlns:a="http://schemas.openxmlformats.org/drawingml/2006/main">
             <a:pPr algn="l">
+              <a:buNone/>
               <a:defRPr sz="1350" b="0">
                 <a:solidFill>
                   <a:srgbClr val="26232A"/>
@@ -17627,6 +17888,7 @@
           <a:lstStyle xmlns:a="http://schemas.openxmlformats.org/drawingml/2006/main"/>
           <a:p xmlns:a="http://schemas.openxmlformats.org/drawingml/2006/main">
             <a:pPr algn="l">
+              <a:buNone/>
               <a:defRPr sz="1275" b="1">
                 <a:solidFill>
                   <a:srgbClr val="E63888"/>
@@ -17677,6 +17939,7 @@
           <a:lstStyle xmlns:a="http://schemas.openxmlformats.org/drawingml/2006/main"/>
           <a:p xmlns:a="http://schemas.openxmlformats.org/drawingml/2006/main">
             <a:pPr algn="l">
+              <a:buNone/>
               <a:defRPr sz="1350" b="0">
                 <a:solidFill>
                   <a:srgbClr val="26232A"/>
@@ -17727,6 +17990,7 @@
           <a:lstStyle xmlns:a="http://schemas.openxmlformats.org/drawingml/2006/main"/>
           <a:p xmlns:a="http://schemas.openxmlformats.org/drawingml/2006/main">
             <a:pPr algn="l">
+              <a:buNone/>
               <a:defRPr sz="1275" b="1">
                 <a:solidFill>
                   <a:srgbClr val="E63888"/>
@@ -17777,6 +18041,7 @@
           <a:lstStyle xmlns:a="http://schemas.openxmlformats.org/drawingml/2006/main"/>
           <a:p xmlns:a="http://schemas.openxmlformats.org/drawingml/2006/main">
             <a:pPr algn="l">
+              <a:buNone/>
               <a:defRPr sz="1350" b="0">
                 <a:solidFill>
                   <a:srgbClr val="26232A"/>
@@ -17827,6 +18092,7 @@
           <a:lstStyle xmlns:a="http://schemas.openxmlformats.org/drawingml/2006/main"/>
           <a:p xmlns:a="http://schemas.openxmlformats.org/drawingml/2006/main">
             <a:pPr algn="l">
+              <a:buNone/>
               <a:defRPr sz="1275" b="1">
                 <a:solidFill>
                   <a:srgbClr val="E63888"/>
@@ -17877,6 +18143,7 @@
           <a:lstStyle xmlns:a="http://schemas.openxmlformats.org/drawingml/2006/main"/>
           <a:p xmlns:a="http://schemas.openxmlformats.org/drawingml/2006/main">
             <a:pPr algn="l">
+              <a:buNone/>
               <a:defRPr sz="1350" b="0">
                 <a:solidFill>
                   <a:srgbClr val="26232A"/>
@@ -17927,6 +18194,7 @@
           <a:lstStyle xmlns:a="http://schemas.openxmlformats.org/drawingml/2006/main"/>
           <a:p xmlns:a="http://schemas.openxmlformats.org/drawingml/2006/main">
             <a:pPr algn="l">
+              <a:buNone/>
               <a:defRPr sz="1275" b="1">
                 <a:solidFill>
                   <a:srgbClr val="E63888"/>
@@ -17977,6 +18245,7 @@
           <a:lstStyle xmlns:a="http://schemas.openxmlformats.org/drawingml/2006/main"/>
           <a:p xmlns:a="http://schemas.openxmlformats.org/drawingml/2006/main">
             <a:pPr algn="l">
+              <a:buNone/>
               <a:defRPr sz="1350" b="0">
                 <a:solidFill>
                   <a:srgbClr val="26232A"/>
@@ -18027,6 +18296,7 @@
           <a:lstStyle xmlns:a="http://schemas.openxmlformats.org/drawingml/2006/main"/>
           <a:p xmlns:a="http://schemas.openxmlformats.org/drawingml/2006/main">
             <a:pPr algn="l">
+              <a:buNone/>
               <a:defRPr sz="1275" b="1">
                 <a:solidFill>
                   <a:srgbClr val="E63888"/>
@@ -18077,6 +18347,7 @@
           <a:lstStyle xmlns:a="http://schemas.openxmlformats.org/drawingml/2006/main"/>
           <a:p xmlns:a="http://schemas.openxmlformats.org/drawingml/2006/main">
             <a:pPr algn="l">
+              <a:buNone/>
               <a:defRPr sz="1350" b="0">
                 <a:solidFill>
                   <a:srgbClr val="26232A"/>
@@ -18127,6 +18398,7 @@
           <a:lstStyle xmlns:a="http://schemas.openxmlformats.org/drawingml/2006/main"/>
           <a:p xmlns:a="http://schemas.openxmlformats.org/drawingml/2006/main">
             <a:pPr algn="l">
+              <a:buNone/>
               <a:defRPr sz="1275" b="1">
                 <a:solidFill>
                   <a:srgbClr val="E63888"/>
@@ -18177,6 +18449,7 @@
           <a:lstStyle xmlns:a="http://schemas.openxmlformats.org/drawingml/2006/main"/>
           <a:p xmlns:a="http://schemas.openxmlformats.org/drawingml/2006/main">
             <a:pPr algn="l">
+              <a:buNone/>
               <a:defRPr sz="1350" b="0">
                 <a:solidFill>
                   <a:srgbClr val="26232A"/>
@@ -18227,6 +18500,7 @@
           <a:lstStyle xmlns:a="http://schemas.openxmlformats.org/drawingml/2006/main"/>
           <a:p xmlns:a="http://schemas.openxmlformats.org/drawingml/2006/main">
             <a:pPr algn="l">
+              <a:buNone/>
               <a:defRPr sz="1275" b="1">
                 <a:solidFill>
                   <a:srgbClr val="E63888"/>
@@ -18277,6 +18551,7 @@
           <a:lstStyle xmlns:a="http://schemas.openxmlformats.org/drawingml/2006/main"/>
           <a:p xmlns:a="http://schemas.openxmlformats.org/drawingml/2006/main">
             <a:pPr algn="l">
+              <a:buNone/>
               <a:defRPr sz="1350" b="0">
                 <a:solidFill>
                   <a:srgbClr val="26232A"/>
@@ -18327,6 +18602,7 @@
           <a:lstStyle xmlns:a="http://schemas.openxmlformats.org/drawingml/2006/main"/>
           <a:p xmlns:a="http://schemas.openxmlformats.org/drawingml/2006/main">
             <a:pPr algn="l">
+              <a:buNone/>
               <a:defRPr sz="1275" b="1">
                 <a:solidFill>
                   <a:srgbClr val="E63888"/>
@@ -18377,6 +18653,7 @@
           <a:lstStyle xmlns:a="http://schemas.openxmlformats.org/drawingml/2006/main"/>
           <a:p xmlns:a="http://schemas.openxmlformats.org/drawingml/2006/main">
             <a:pPr algn="l">
+              <a:buNone/>
               <a:defRPr sz="1350" b="0">
                 <a:solidFill>
                   <a:srgbClr val="26232A"/>
@@ -18427,6 +18704,7 @@
           <a:lstStyle xmlns:a="http://schemas.openxmlformats.org/drawingml/2006/main"/>
           <a:p xmlns:a="http://schemas.openxmlformats.org/drawingml/2006/main">
             <a:pPr algn="l">
+              <a:buNone/>
               <a:defRPr sz="1650" b="1">
                 <a:solidFill>
                   <a:srgbClr val="3D1F5C"/>
@@ -18506,6 +18784,7 @@
           <a:lstStyle xmlns:a="http://schemas.openxmlformats.org/drawingml/2006/main"/>
           <a:p xmlns:a="http://schemas.openxmlformats.org/drawingml/2006/main">
             <a:pPr algn="l">
+              <a:buNone/>
               <a:defRPr sz="1800" b="1">
                 <a:solidFill>
                   <a:srgbClr val="E63888"/>
@@ -18587,6 +18866,7 @@
           <a:lstStyle xmlns:a="http://schemas.openxmlformats.org/drawingml/2006/main"/>
           <a:p xmlns:a="http://schemas.openxmlformats.org/drawingml/2006/main">
             <a:pPr algn="l">
+              <a:buNone/>
               <a:defRPr sz="3150" b="1">
                 <a:solidFill>
                   <a:srgbClr val="FFFFFF"/>
@@ -18637,6 +18917,7 @@
           <a:lstStyle xmlns:a="http://schemas.openxmlformats.org/drawingml/2006/main"/>
           <a:p xmlns:a="http://schemas.openxmlformats.org/drawingml/2006/main">
             <a:pPr algn="l">
+              <a:buNone/>
               <a:defRPr sz="750" b="1">
                 <a:solidFill>
                   <a:srgbClr val="EAE3EC"/>
@@ -18687,6 +18968,7 @@
           <a:lstStyle xmlns:a="http://schemas.openxmlformats.org/drawingml/2006/main"/>
           <a:p xmlns:a="http://schemas.openxmlformats.org/drawingml/2006/main">
             <a:pPr algn="r">
+              <a:buNone/>
               <a:defRPr sz="825" b="1">
                 <a:solidFill>
                   <a:srgbClr val="C7F25C"/>
@@ -18737,6 +19019,7 @@
           <a:lstStyle xmlns:a="http://schemas.openxmlformats.org/drawingml/2006/main"/>
           <a:p xmlns:a="http://schemas.openxmlformats.org/drawingml/2006/main">
             <a:pPr algn="l">
+              <a:buNone/>
               <a:defRPr sz="2100" b="1">
                 <a:solidFill>
                   <a:srgbClr val="FFFFFF"/>
@@ -18787,6 +19070,7 @@
           <a:lstStyle xmlns:a="http://schemas.openxmlformats.org/drawingml/2006/main"/>
           <a:p xmlns:a="http://schemas.openxmlformats.org/drawingml/2006/main">
             <a:pPr algn="l">
+              <a:buNone/>
               <a:defRPr sz="2100" b="1">
                 <a:solidFill>
                   <a:srgbClr val="E63888"/>
@@ -18837,6 +19121,7 @@
           <a:lstStyle xmlns:a="http://schemas.openxmlformats.org/drawingml/2006/main"/>
           <a:p xmlns:a="http://schemas.openxmlformats.org/drawingml/2006/main">
             <a:pPr algn="l">
+              <a:buNone/>
               <a:defRPr sz="2100" b="1">
                 <a:solidFill>
                   <a:srgbClr val="C7F25C"/>
@@ -18887,6 +19172,7 @@
           <a:lstStyle xmlns:a="http://schemas.openxmlformats.org/drawingml/2006/main"/>
           <a:p xmlns:a="http://schemas.openxmlformats.org/drawingml/2006/main">
             <a:pPr algn="l">
+              <a:buNone/>
               <a:defRPr sz="1500" b="0">
                 <a:solidFill>
                   <a:srgbClr val="EAE3EC"/>
@@ -18937,6 +19223,7 @@
           <a:lstStyle xmlns:a="http://schemas.openxmlformats.org/drawingml/2006/main"/>
           <a:p xmlns:a="http://schemas.openxmlformats.org/drawingml/2006/main">
             <a:pPr algn="l">
+              <a:buNone/>
               <a:defRPr sz="1650" b="1">
                 <a:solidFill>
                   <a:srgbClr val="FFFFFF"/>
@@ -18956,14 +19243,14 @@
       </p:sp>
       <p:pic>
         <p:nvPicPr>
-          <p:cNvPr id="22" name=""/>
+          <p:cNvPr id="24" name=""/>
           <p:cNvPicPr>
             <a:picLocks xmlns:a="http://schemas.openxmlformats.org/drawingml/2006/main" noChangeAspect="1"/>
           </p:cNvPicPr>
           <p:nvPr/>
         </p:nvPicPr>
         <p:blipFill>
-          <a:blip xmlns:r="http://schemas.openxmlformats.org/officeDocument/2006/relationships" xmlns:a="http://schemas.openxmlformats.org/drawingml/2006/main" r:embed="R3505a2f4fe5d42d5"/>
+          <a:blip xmlns:r="http://schemas.openxmlformats.org/officeDocument/2006/relationships" xmlns:a="http://schemas.openxmlformats.org/drawingml/2006/main" r:embed="Rc21bb8fb53204259"/>
           <a:stretch xmlns:a="http://schemas.openxmlformats.org/drawingml/2006/main"/>
         </p:blipFill>
         <p:spPr>
@@ -19038,6 +19325,7 @@
           <a:lstStyle xmlns:a="http://schemas.openxmlformats.org/drawingml/2006/main"/>
           <a:p xmlns:a="http://schemas.openxmlformats.org/drawingml/2006/main">
             <a:pPr algn="l">
+              <a:buNone/>
               <a:defRPr sz="1800" b="1">
                 <a:solidFill>
                   <a:srgbClr val="E63888"/>
@@ -19119,6 +19407,7 @@
           <a:lstStyle xmlns:a="http://schemas.openxmlformats.org/drawingml/2006/main"/>
           <a:p xmlns:a="http://schemas.openxmlformats.org/drawingml/2006/main">
             <a:pPr algn="l">
+              <a:buNone/>
               <a:defRPr sz="3150" b="1">
                 <a:solidFill>
                   <a:srgbClr val="FFFFFF"/>
@@ -19169,6 +19458,7 @@
           <a:lstStyle xmlns:a="http://schemas.openxmlformats.org/drawingml/2006/main"/>
           <a:p xmlns:a="http://schemas.openxmlformats.org/drawingml/2006/main">
             <a:pPr algn="l">
+              <a:buNone/>
               <a:defRPr sz="750" b="1">
                 <a:solidFill>
                   <a:srgbClr val="EAE3EC"/>
@@ -19219,6 +19509,7 @@
           <a:lstStyle xmlns:a="http://schemas.openxmlformats.org/drawingml/2006/main"/>
           <a:p xmlns:a="http://schemas.openxmlformats.org/drawingml/2006/main">
             <a:pPr algn="r">
+              <a:buNone/>
               <a:defRPr sz="825" b="1">
                 <a:solidFill>
                   <a:srgbClr val="C7F25C"/>
@@ -19304,6 +19595,7 @@
           <a:lstStyle xmlns:a="http://schemas.openxmlformats.org/drawingml/2006/main"/>
           <a:p xmlns:a="http://schemas.openxmlformats.org/drawingml/2006/main">
             <a:pPr algn="l">
+              <a:buNone/>
               <a:defRPr sz="1500" b="1">
                 <a:solidFill>
                   <a:srgbClr val="C7F25C"/>
@@ -19354,6 +19646,7 @@
           <a:lstStyle xmlns:a="http://schemas.openxmlformats.org/drawingml/2006/main"/>
           <a:p xmlns:a="http://schemas.openxmlformats.org/drawingml/2006/main">
             <a:pPr algn="l">
+              <a:buNone/>
               <a:defRPr sz="1275" b="1">
                 <a:solidFill>
                   <a:srgbClr val="FFFFFF"/>
@@ -19371,6 +19664,7 @@
           </a:p>
           <a:p xmlns:a="http://schemas.openxmlformats.org/drawingml/2006/main">
             <a:pPr algn="l">
+              <a:buNone/>
               <a:defRPr sz="1275" b="1">
                 <a:solidFill>
                   <a:srgbClr val="FFFFFF"/>
@@ -19456,6 +19750,7 @@
           <a:lstStyle xmlns:a="http://schemas.openxmlformats.org/drawingml/2006/main"/>
           <a:p xmlns:a="http://schemas.openxmlformats.org/drawingml/2006/main">
             <a:pPr algn="l">
+              <a:buNone/>
               <a:defRPr sz="1500" b="1">
                 <a:solidFill>
                   <a:srgbClr val="C7F25C"/>
@@ -19506,6 +19801,7 @@
           <a:lstStyle xmlns:a="http://schemas.openxmlformats.org/drawingml/2006/main"/>
           <a:p xmlns:a="http://schemas.openxmlformats.org/drawingml/2006/main">
             <a:pPr algn="l">
+              <a:buNone/>
               <a:defRPr sz="1275" b="1">
                 <a:solidFill>
                   <a:srgbClr val="FFFFFF"/>
@@ -19523,6 +19819,7 @@
           </a:p>
           <a:p xmlns:a="http://schemas.openxmlformats.org/drawingml/2006/main">
             <a:pPr algn="l">
+              <a:buNone/>
               <a:defRPr sz="1275" b="1">
                 <a:solidFill>
                   <a:srgbClr val="FFFFFF"/>
@@ -19608,6 +19905,7 @@
           <a:lstStyle xmlns:a="http://schemas.openxmlformats.org/drawingml/2006/main"/>
           <a:p xmlns:a="http://schemas.openxmlformats.org/drawingml/2006/main">
             <a:pPr algn="l">
+              <a:buNone/>
               <a:defRPr sz="1500" b="1">
                 <a:solidFill>
                   <a:srgbClr val="C7F25C"/>
@@ -19658,6 +19956,7 @@
           <a:lstStyle xmlns:a="http://schemas.openxmlformats.org/drawingml/2006/main"/>
           <a:p xmlns:a="http://schemas.openxmlformats.org/drawingml/2006/main">
             <a:pPr algn="l">
+              <a:buNone/>
               <a:defRPr sz="1275" b="1">
                 <a:solidFill>
                   <a:srgbClr val="FFFFFF"/>
@@ -19675,6 +19974,7 @@
           </a:p>
           <a:p xmlns:a="http://schemas.openxmlformats.org/drawingml/2006/main">
             <a:pPr algn="l">
+              <a:buNone/>
               <a:defRPr sz="1275" b="1">
                 <a:solidFill>
                   <a:srgbClr val="FFFFFF"/>
@@ -19760,6 +20060,7 @@
           <a:lstStyle xmlns:a="http://schemas.openxmlformats.org/drawingml/2006/main"/>
           <a:p xmlns:a="http://schemas.openxmlformats.org/drawingml/2006/main">
             <a:pPr algn="l">
+              <a:buNone/>
               <a:defRPr sz="1500" b="1">
                 <a:solidFill>
                   <a:srgbClr val="C7F25C"/>
@@ -19810,6 +20111,7 @@
           <a:lstStyle xmlns:a="http://schemas.openxmlformats.org/drawingml/2006/main"/>
           <a:p xmlns:a="http://schemas.openxmlformats.org/drawingml/2006/main">
             <a:pPr algn="l">
+              <a:buNone/>
               <a:defRPr sz="1275" b="1">
                 <a:solidFill>
                   <a:srgbClr val="FFFFFF"/>
@@ -19827,6 +20129,7 @@
           </a:p>
           <a:p xmlns:a="http://schemas.openxmlformats.org/drawingml/2006/main">
             <a:pPr algn="l">
+              <a:buNone/>
               <a:defRPr sz="1275" b="1">
                 <a:solidFill>
                   <a:srgbClr val="FFFFFF"/>
@@ -19912,6 +20215,7 @@
           <a:lstStyle xmlns:a="http://schemas.openxmlformats.org/drawingml/2006/main"/>
           <a:p xmlns:a="http://schemas.openxmlformats.org/drawingml/2006/main">
             <a:pPr algn="l">
+              <a:buNone/>
               <a:defRPr sz="1500" b="1">
                 <a:solidFill>
                   <a:srgbClr val="C7F25C"/>
@@ -19962,6 +20266,7 @@
           <a:lstStyle xmlns:a="http://schemas.openxmlformats.org/drawingml/2006/main"/>
           <a:p xmlns:a="http://schemas.openxmlformats.org/drawingml/2006/main">
             <a:pPr algn="l">
+              <a:buNone/>
               <a:defRPr sz="1275" b="1">
                 <a:solidFill>
                   <a:srgbClr val="FFFFFF"/>
@@ -19979,6 +20284,7 @@
           </a:p>
           <a:p xmlns:a="http://schemas.openxmlformats.org/drawingml/2006/main">
             <a:pPr algn="l">
+              <a:buNone/>
               <a:defRPr sz="1275" b="1">
                 <a:solidFill>
                   <a:srgbClr val="FFFFFF"/>
@@ -20064,6 +20370,7 @@
           <a:lstStyle xmlns:a="http://schemas.openxmlformats.org/drawingml/2006/main"/>
           <a:p xmlns:a="http://schemas.openxmlformats.org/drawingml/2006/main">
             <a:pPr algn="l">
+              <a:buNone/>
               <a:defRPr sz="1500" b="1">
                 <a:solidFill>
                   <a:srgbClr val="C7F25C"/>
@@ -20114,6 +20421,7 @@
           <a:lstStyle xmlns:a="http://schemas.openxmlformats.org/drawingml/2006/main"/>
           <a:p xmlns:a="http://schemas.openxmlformats.org/drawingml/2006/main">
             <a:pPr algn="l">
+              <a:buNone/>
               <a:defRPr sz="1050" b="1">
                 <a:solidFill>
                   <a:srgbClr val="FFFFFF"/>
@@ -20131,6 +20439,7 @@
           </a:p>
           <a:p xmlns:a="http://schemas.openxmlformats.org/drawingml/2006/main">
             <a:pPr algn="l">
+              <a:buNone/>
               <a:defRPr sz="1050" b="1">
                 <a:solidFill>
                   <a:srgbClr val="FFFFFF"/>
@@ -20181,6 +20490,7 @@
           <a:lstStyle xmlns:a="http://schemas.openxmlformats.org/drawingml/2006/main"/>
           <a:p xmlns:a="http://schemas.openxmlformats.org/drawingml/2006/main">
             <a:pPr algn="ctr">
+              <a:buNone/>
               <a:defRPr sz="1650" b="1">
                 <a:solidFill>
                   <a:srgbClr val="FFFFFF"/>
@@ -20260,6 +20570,7 @@
           <a:lstStyle xmlns:a="http://schemas.openxmlformats.org/drawingml/2006/main"/>
           <a:p xmlns:a="http://schemas.openxmlformats.org/drawingml/2006/main">
             <a:pPr algn="l">
+              <a:buNone/>
               <a:defRPr sz="1800" b="1">
                 <a:solidFill>
                   <a:srgbClr val="E63888"/>
@@ -20341,6 +20652,7 @@
           <a:lstStyle xmlns:a="http://schemas.openxmlformats.org/drawingml/2006/main"/>
           <a:p xmlns:a="http://schemas.openxmlformats.org/drawingml/2006/main">
             <a:pPr algn="l">
+              <a:buNone/>
               <a:defRPr sz="3150" b="1">
                 <a:solidFill>
                   <a:srgbClr val="26232A"/>
@@ -20391,6 +20703,7 @@
           <a:lstStyle xmlns:a="http://schemas.openxmlformats.org/drawingml/2006/main"/>
           <a:p xmlns:a="http://schemas.openxmlformats.org/drawingml/2006/main">
             <a:pPr algn="l">
+              <a:buNone/>
               <a:defRPr sz="750" b="1">
                 <a:solidFill>
                   <a:srgbClr val="6E6873"/>
@@ -20441,6 +20754,7 @@
           <a:lstStyle xmlns:a="http://schemas.openxmlformats.org/drawingml/2006/main"/>
           <a:p xmlns:a="http://schemas.openxmlformats.org/drawingml/2006/main">
             <a:pPr algn="r">
+              <a:buNone/>
               <a:defRPr sz="825" b="1">
                 <a:solidFill>
                   <a:srgbClr val="E63888"/>
@@ -20526,6 +20840,7 @@
           <a:lstStyle xmlns:a="http://schemas.openxmlformats.org/drawingml/2006/main"/>
           <a:p xmlns:a="http://schemas.openxmlformats.org/drawingml/2006/main">
             <a:pPr algn="l">
+              <a:buNone/>
               <a:defRPr sz="975" b="1">
                 <a:solidFill>
                   <a:srgbClr val="E63888"/>
@@ -20576,6 +20891,7 @@
           <a:lstStyle xmlns:a="http://schemas.openxmlformats.org/drawingml/2006/main"/>
           <a:p xmlns:a="http://schemas.openxmlformats.org/drawingml/2006/main">
             <a:pPr algn="l">
+              <a:buNone/>
               <a:defRPr sz="1425" b="0">
                 <a:solidFill>
                   <a:srgbClr val="26232A"/>
@@ -20659,6 +20975,7 @@
           <a:lstStyle xmlns:a="http://schemas.openxmlformats.org/drawingml/2006/main"/>
           <a:p xmlns:a="http://schemas.openxmlformats.org/drawingml/2006/main">
             <a:pPr algn="l">
+              <a:buNone/>
               <a:defRPr sz="975" b="1">
                 <a:solidFill>
                   <a:srgbClr val="C7F25C"/>
@@ -20709,6 +21026,7 @@
           <a:lstStyle xmlns:a="http://schemas.openxmlformats.org/drawingml/2006/main"/>
           <a:p xmlns:a="http://schemas.openxmlformats.org/drawingml/2006/main">
             <a:pPr algn="l">
+              <a:buNone/>
               <a:defRPr sz="1650" b="1">
                 <a:solidFill>
                   <a:srgbClr val="FFFFFF"/>
@@ -20759,6 +21077,7 @@
           <a:lstStyle xmlns:a="http://schemas.openxmlformats.org/drawingml/2006/main"/>
           <a:p xmlns:a="http://schemas.openxmlformats.org/drawingml/2006/main">
             <a:pPr algn="l">
+              <a:buNone/>
               <a:defRPr sz="2400" b="1">
                 <a:solidFill>
                   <a:srgbClr val="E63888"/>
@@ -20842,6 +21161,7 @@
           <a:lstStyle xmlns:a="http://schemas.openxmlformats.org/drawingml/2006/main"/>
           <a:p xmlns:a="http://schemas.openxmlformats.org/drawingml/2006/main">
             <a:pPr algn="l">
+              <a:buNone/>
               <a:defRPr sz="975" b="1">
                 <a:solidFill>
                   <a:srgbClr val="3D1F5C"/>
@@ -20892,6 +21212,7 @@
           <a:lstStyle xmlns:a="http://schemas.openxmlformats.org/drawingml/2006/main"/>
           <a:p xmlns:a="http://schemas.openxmlformats.org/drawingml/2006/main">
             <a:pPr algn="l">
+              <a:buNone/>
               <a:defRPr sz="1350" b="1">
                 <a:solidFill>
                   <a:srgbClr val="3D1F5C"/>
@@ -20971,6 +21292,7 @@
           <a:lstStyle xmlns:a="http://schemas.openxmlformats.org/drawingml/2006/main"/>
           <a:p xmlns:a="http://schemas.openxmlformats.org/drawingml/2006/main">
             <a:pPr algn="l">
+              <a:buNone/>
               <a:defRPr sz="1800" b="1">
                 <a:solidFill>
                   <a:srgbClr val="E63888"/>
@@ -21052,6 +21374,7 @@
           <a:lstStyle xmlns:a="http://schemas.openxmlformats.org/drawingml/2006/main"/>
           <a:p xmlns:a="http://schemas.openxmlformats.org/drawingml/2006/main">
             <a:pPr algn="l">
+              <a:buNone/>
               <a:defRPr sz="3150" b="1">
                 <a:solidFill>
                   <a:srgbClr val="26232A"/>
@@ -21102,6 +21425,7 @@
           <a:lstStyle xmlns:a="http://schemas.openxmlformats.org/drawingml/2006/main"/>
           <a:p xmlns:a="http://schemas.openxmlformats.org/drawingml/2006/main">
             <a:pPr algn="l">
+              <a:buNone/>
               <a:defRPr sz="750" b="1">
                 <a:solidFill>
                   <a:srgbClr val="6E6873"/>
@@ -21152,6 +21476,7 @@
           <a:lstStyle xmlns:a="http://schemas.openxmlformats.org/drawingml/2006/main"/>
           <a:p xmlns:a="http://schemas.openxmlformats.org/drawingml/2006/main">
             <a:pPr algn="r">
+              <a:buNone/>
               <a:defRPr sz="825" b="1">
                 <a:solidFill>
                   <a:srgbClr val="E63888"/>
@@ -21237,6 +21562,7 @@
           <a:lstStyle xmlns:a="http://schemas.openxmlformats.org/drawingml/2006/main"/>
           <a:p xmlns:a="http://schemas.openxmlformats.org/drawingml/2006/main">
             <a:pPr algn="l">
+              <a:buNone/>
               <a:defRPr sz="975" b="1">
                 <a:solidFill>
                   <a:srgbClr val="E63888"/>
@@ -21287,6 +21613,7 @@
           <a:lstStyle xmlns:a="http://schemas.openxmlformats.org/drawingml/2006/main"/>
           <a:p xmlns:a="http://schemas.openxmlformats.org/drawingml/2006/main">
             <a:pPr algn="l">
+              <a:buNone/>
               <a:defRPr sz="1425" b="0">
                 <a:solidFill>
                   <a:srgbClr val="26232A"/>
@@ -21370,6 +21697,7 @@
           <a:lstStyle xmlns:a="http://schemas.openxmlformats.org/drawingml/2006/main"/>
           <a:p xmlns:a="http://schemas.openxmlformats.org/drawingml/2006/main">
             <a:pPr algn="l">
+              <a:buNone/>
               <a:defRPr sz="975" b="1">
                 <a:solidFill>
                   <a:srgbClr val="C7F25C"/>
@@ -21420,6 +21748,7 @@
           <a:lstStyle xmlns:a="http://schemas.openxmlformats.org/drawingml/2006/main"/>
           <a:p xmlns:a="http://schemas.openxmlformats.org/drawingml/2006/main">
             <a:pPr algn="l">
+              <a:buNone/>
               <a:defRPr sz="1650" b="1">
                 <a:solidFill>
                   <a:srgbClr val="FFFFFF"/>
@@ -21470,6 +21799,7 @@
           <a:lstStyle xmlns:a="http://schemas.openxmlformats.org/drawingml/2006/main"/>
           <a:p xmlns:a="http://schemas.openxmlformats.org/drawingml/2006/main">
             <a:pPr algn="l">
+              <a:buNone/>
               <a:defRPr sz="1650" b="1">
                 <a:solidFill>
                   <a:srgbClr val="3D1F5C"/>
@@ -21553,6 +21883,7 @@
           <a:lstStyle xmlns:a="http://schemas.openxmlformats.org/drawingml/2006/main"/>
           <a:p xmlns:a="http://schemas.openxmlformats.org/drawingml/2006/main">
             <a:pPr algn="l">
+              <a:buNone/>
               <a:defRPr sz="975" b="1">
                 <a:solidFill>
                   <a:srgbClr val="3D1F5C"/>
@@ -21603,6 +21934,7 @@
           <a:lstStyle xmlns:a="http://schemas.openxmlformats.org/drawingml/2006/main"/>
           <a:p xmlns:a="http://schemas.openxmlformats.org/drawingml/2006/main">
             <a:pPr algn="l">
+              <a:buNone/>
               <a:defRPr sz="1350" b="1">
                 <a:solidFill>
                   <a:srgbClr val="3D1F5C"/>
@@ -21682,6 +22014,7 @@
           <a:lstStyle xmlns:a="http://schemas.openxmlformats.org/drawingml/2006/main"/>
           <a:p xmlns:a="http://schemas.openxmlformats.org/drawingml/2006/main">
             <a:pPr algn="l">
+              <a:buNone/>
               <a:defRPr sz="1800" b="1">
                 <a:solidFill>
                   <a:srgbClr val="E63888"/>
@@ -21763,6 +22096,7 @@
           <a:lstStyle xmlns:a="http://schemas.openxmlformats.org/drawingml/2006/main"/>
           <a:p xmlns:a="http://schemas.openxmlformats.org/drawingml/2006/main">
             <a:pPr algn="l">
+              <a:buNone/>
               <a:defRPr sz="3150" b="1">
                 <a:solidFill>
                   <a:srgbClr val="26232A"/>
@@ -21813,6 +22147,7 @@
           <a:lstStyle xmlns:a="http://schemas.openxmlformats.org/drawingml/2006/main"/>
           <a:p xmlns:a="http://schemas.openxmlformats.org/drawingml/2006/main">
             <a:pPr algn="l">
+              <a:buNone/>
               <a:defRPr sz="750" b="1">
                 <a:solidFill>
                   <a:srgbClr val="6E6873"/>
@@ -21863,6 +22198,7 @@
           <a:lstStyle xmlns:a="http://schemas.openxmlformats.org/drawingml/2006/main"/>
           <a:p xmlns:a="http://schemas.openxmlformats.org/drawingml/2006/main">
             <a:pPr algn="r">
+              <a:buNone/>
               <a:defRPr sz="825" b="1">
                 <a:solidFill>
                   <a:srgbClr val="E63888"/>
@@ -21948,6 +22284,7 @@
           <a:lstStyle xmlns:a="http://schemas.openxmlformats.org/drawingml/2006/main"/>
           <a:p xmlns:a="http://schemas.openxmlformats.org/drawingml/2006/main">
             <a:pPr algn="l">
+              <a:buNone/>
               <a:defRPr sz="975" b="1">
                 <a:solidFill>
                   <a:srgbClr val="E63888"/>
@@ -21998,6 +22335,7 @@
           <a:lstStyle xmlns:a="http://schemas.openxmlformats.org/drawingml/2006/main"/>
           <a:p xmlns:a="http://schemas.openxmlformats.org/drawingml/2006/main">
             <a:pPr algn="l">
+              <a:buNone/>
               <a:defRPr sz="1425" b="0">
                 <a:solidFill>
                   <a:srgbClr val="26232A"/>
@@ -22081,6 +22419,7 @@
           <a:lstStyle xmlns:a="http://schemas.openxmlformats.org/drawingml/2006/main"/>
           <a:p xmlns:a="http://schemas.openxmlformats.org/drawingml/2006/main">
             <a:pPr algn="l">
+              <a:buNone/>
               <a:defRPr sz="975" b="1">
                 <a:solidFill>
                   <a:srgbClr val="C7F25C"/>
@@ -22131,6 +22470,7 @@
           <a:lstStyle xmlns:a="http://schemas.openxmlformats.org/drawingml/2006/main"/>
           <a:p xmlns:a="http://schemas.openxmlformats.org/drawingml/2006/main">
             <a:pPr algn="l">
+              <a:buNone/>
               <a:defRPr sz="1650" b="1">
                 <a:solidFill>
                   <a:srgbClr val="FFFFFF"/>
@@ -22181,6 +22521,7 @@
           <a:lstStyle xmlns:a="http://schemas.openxmlformats.org/drawingml/2006/main"/>
           <a:p xmlns:a="http://schemas.openxmlformats.org/drawingml/2006/main">
             <a:pPr algn="ctr">
+              <a:buNone/>
               <a:defRPr sz="2250" b="1">
                 <a:solidFill>
                   <a:srgbClr val="E63888"/>
@@ -22264,6 +22605,7 @@
           <a:lstStyle xmlns:a="http://schemas.openxmlformats.org/drawingml/2006/main"/>
           <a:p xmlns:a="http://schemas.openxmlformats.org/drawingml/2006/main">
             <a:pPr algn="l">
+              <a:buNone/>
               <a:defRPr sz="975" b="1">
                 <a:solidFill>
                   <a:srgbClr val="3D1F5C"/>
@@ -22314,6 +22656,7 @@
           <a:lstStyle xmlns:a="http://schemas.openxmlformats.org/drawingml/2006/main"/>
           <a:p xmlns:a="http://schemas.openxmlformats.org/drawingml/2006/main">
             <a:pPr algn="l">
+              <a:buNone/>
               <a:defRPr sz="1350" b="1">
                 <a:solidFill>
                   <a:srgbClr val="3D1F5C"/>
@@ -22393,6 +22736,7 @@
           <a:lstStyle xmlns:a="http://schemas.openxmlformats.org/drawingml/2006/main"/>
           <a:p xmlns:a="http://schemas.openxmlformats.org/drawingml/2006/main">
             <a:pPr algn="l">
+              <a:buNone/>
               <a:defRPr sz="1800" b="1">
                 <a:solidFill>
                   <a:srgbClr val="E63888"/>
@@ -22474,6 +22818,7 @@
           <a:lstStyle xmlns:a="http://schemas.openxmlformats.org/drawingml/2006/main"/>
           <a:p xmlns:a="http://schemas.openxmlformats.org/drawingml/2006/main">
             <a:pPr algn="l">
+              <a:buNone/>
               <a:defRPr sz="3150" b="1">
                 <a:solidFill>
                   <a:srgbClr val="26232A"/>
@@ -22524,6 +22869,7 @@
           <a:lstStyle xmlns:a="http://schemas.openxmlformats.org/drawingml/2006/main"/>
           <a:p xmlns:a="http://schemas.openxmlformats.org/drawingml/2006/main">
             <a:pPr algn="l">
+              <a:buNone/>
               <a:defRPr sz="750" b="1">
                 <a:solidFill>
                   <a:srgbClr val="6E6873"/>
@@ -22574,6 +22920,7 @@
           <a:lstStyle xmlns:a="http://schemas.openxmlformats.org/drawingml/2006/main"/>
           <a:p xmlns:a="http://schemas.openxmlformats.org/drawingml/2006/main">
             <a:pPr algn="r">
+              <a:buNone/>
               <a:defRPr sz="825" b="1">
                 <a:solidFill>
                   <a:srgbClr val="E63888"/>
@@ -22657,6 +23004,7 @@
           <a:lstStyle xmlns:a="http://schemas.openxmlformats.org/drawingml/2006/main"/>
           <a:p xmlns:a="http://schemas.openxmlformats.org/drawingml/2006/main">
             <a:pPr algn="l">
+              <a:buNone/>
               <a:defRPr sz="975" b="1">
                 <a:solidFill>
                   <a:srgbClr val="C7F25C"/>
@@ -22707,6 +23055,7 @@
           <a:lstStyle xmlns:a="http://schemas.openxmlformats.org/drawingml/2006/main"/>
           <a:p xmlns:a="http://schemas.openxmlformats.org/drawingml/2006/main">
             <a:pPr algn="l">
+              <a:buNone/>
               <a:defRPr sz="1350" b="0">
                 <a:solidFill>
                   <a:srgbClr val="FFFFFF"/>
@@ -22757,6 +23106,7 @@
           <a:lstStyle xmlns:a="http://schemas.openxmlformats.org/drawingml/2006/main"/>
           <a:p xmlns:a="http://schemas.openxmlformats.org/drawingml/2006/main">
             <a:pPr algn="l">
+              <a:buNone/>
               <a:defRPr sz="1350" b="0">
                 <a:solidFill>
                   <a:srgbClr val="FFFFFF"/>
@@ -22807,6 +23157,7 @@
           <a:lstStyle xmlns:a="http://schemas.openxmlformats.org/drawingml/2006/main"/>
           <a:p xmlns:a="http://schemas.openxmlformats.org/drawingml/2006/main">
             <a:pPr algn="l">
+              <a:buNone/>
               <a:defRPr sz="1350" b="0">
                 <a:solidFill>
                   <a:srgbClr val="FFFFFF"/>
@@ -22857,6 +23208,7 @@
           <a:lstStyle xmlns:a="http://schemas.openxmlformats.org/drawingml/2006/main"/>
           <a:p xmlns:a="http://schemas.openxmlformats.org/drawingml/2006/main">
             <a:pPr algn="l">
+              <a:buNone/>
               <a:defRPr sz="1350" b="0">
                 <a:solidFill>
                   <a:srgbClr val="FFFFFF"/>
@@ -22907,6 +23259,7 @@
           <a:lstStyle xmlns:a="http://schemas.openxmlformats.org/drawingml/2006/main"/>
           <a:p xmlns:a="http://schemas.openxmlformats.org/drawingml/2006/main">
             <a:pPr algn="l">
+              <a:buNone/>
               <a:defRPr sz="1350" b="0">
                 <a:solidFill>
                   <a:srgbClr val="FFFFFF"/>
@@ -22957,6 +23310,7 @@
           <a:lstStyle xmlns:a="http://schemas.openxmlformats.org/drawingml/2006/main"/>
           <a:p xmlns:a="http://schemas.openxmlformats.org/drawingml/2006/main">
             <a:pPr algn="l">
+              <a:buNone/>
               <a:defRPr sz="1350" b="0">
                 <a:solidFill>
                   <a:srgbClr val="FFFFFF"/>
@@ -23007,6 +23361,7 @@
           <a:lstStyle xmlns:a="http://schemas.openxmlformats.org/drawingml/2006/main"/>
           <a:p xmlns:a="http://schemas.openxmlformats.org/drawingml/2006/main">
             <a:pPr algn="l">
+              <a:buNone/>
               <a:defRPr sz="1350" b="1">
                 <a:solidFill>
                   <a:srgbClr val="C7F25C"/>
@@ -23057,6 +23412,7 @@
           <a:lstStyle xmlns:a="http://schemas.openxmlformats.org/drawingml/2006/main"/>
           <a:p xmlns:a="http://schemas.openxmlformats.org/drawingml/2006/main">
             <a:pPr algn="l">
+              <a:buNone/>
               <a:defRPr sz="1275" b="1">
                 <a:solidFill>
                   <a:srgbClr val="E63888"/>
@@ -23107,6 +23463,7 @@
           <a:lstStyle xmlns:a="http://schemas.openxmlformats.org/drawingml/2006/main"/>
           <a:p xmlns:a="http://schemas.openxmlformats.org/drawingml/2006/main">
             <a:pPr algn="l">
+              <a:buNone/>
               <a:defRPr sz="1350" b="0">
                 <a:solidFill>
                   <a:srgbClr val="26232A"/>
@@ -23157,6 +23514,7 @@
           <a:lstStyle xmlns:a="http://schemas.openxmlformats.org/drawingml/2006/main"/>
           <a:p xmlns:a="http://schemas.openxmlformats.org/drawingml/2006/main">
             <a:pPr algn="l">
+              <a:buNone/>
               <a:defRPr sz="1275" b="1">
                 <a:solidFill>
                   <a:srgbClr val="E63888"/>
@@ -23207,6 +23565,7 @@
           <a:lstStyle xmlns:a="http://schemas.openxmlformats.org/drawingml/2006/main"/>
           <a:p xmlns:a="http://schemas.openxmlformats.org/drawingml/2006/main">
             <a:pPr algn="l">
+              <a:buNone/>
               <a:defRPr sz="1350" b="0">
                 <a:solidFill>
                   <a:srgbClr val="26232A"/>
@@ -23257,6 +23616,7 @@
           <a:lstStyle xmlns:a="http://schemas.openxmlformats.org/drawingml/2006/main"/>
           <a:p xmlns:a="http://schemas.openxmlformats.org/drawingml/2006/main">
             <a:pPr algn="l">
+              <a:buNone/>
               <a:defRPr sz="1275" b="1">
                 <a:solidFill>
                   <a:srgbClr val="E63888"/>
@@ -23307,6 +23667,7 @@
           <a:lstStyle xmlns:a="http://schemas.openxmlformats.org/drawingml/2006/main"/>
           <a:p xmlns:a="http://schemas.openxmlformats.org/drawingml/2006/main">
             <a:pPr algn="l">
+              <a:buNone/>
               <a:defRPr sz="1350" b="0">
                 <a:solidFill>
                   <a:srgbClr val="26232A"/>
@@ -23357,6 +23718,7 @@
           <a:lstStyle xmlns:a="http://schemas.openxmlformats.org/drawingml/2006/main"/>
           <a:p xmlns:a="http://schemas.openxmlformats.org/drawingml/2006/main">
             <a:pPr algn="l">
+              <a:buNone/>
               <a:defRPr sz="1275" b="1">
                 <a:solidFill>
                   <a:srgbClr val="E63888"/>
@@ -23407,6 +23769,7 @@
           <a:lstStyle xmlns:a="http://schemas.openxmlformats.org/drawingml/2006/main"/>
           <a:p xmlns:a="http://schemas.openxmlformats.org/drawingml/2006/main">
             <a:pPr algn="l">
+              <a:buNone/>
               <a:defRPr sz="1350" b="0">
                 <a:solidFill>
                   <a:srgbClr val="26232A"/>
@@ -23457,6 +23820,7 @@
           <a:lstStyle xmlns:a="http://schemas.openxmlformats.org/drawingml/2006/main"/>
           <a:p xmlns:a="http://schemas.openxmlformats.org/drawingml/2006/main">
             <a:pPr algn="l">
+              <a:buNone/>
               <a:defRPr sz="1275" b="1">
                 <a:solidFill>
                   <a:srgbClr val="E63888"/>
@@ -23507,6 +23871,7 @@
           <a:lstStyle xmlns:a="http://schemas.openxmlformats.org/drawingml/2006/main"/>
           <a:p xmlns:a="http://schemas.openxmlformats.org/drawingml/2006/main">
             <a:pPr algn="l">
+              <a:buNone/>
               <a:defRPr sz="1350" b="0">
                 <a:solidFill>
                   <a:srgbClr val="26232A"/>
@@ -23557,6 +23922,7 @@
           <a:lstStyle xmlns:a="http://schemas.openxmlformats.org/drawingml/2006/main"/>
           <a:p xmlns:a="http://schemas.openxmlformats.org/drawingml/2006/main">
             <a:pPr algn="l">
+              <a:buNone/>
               <a:defRPr sz="1350" b="1">
                 <a:solidFill>
                   <a:srgbClr val="3D1F5C"/>

</xml_diff>